<commit_message>
Update introduction slides with new template
- 新しいタイトルスライドフォーマットを適用
- output/ フォルダの説明スライドを追加
- コード例を新しいシグネチャに更新
- 全16スライド

Co-Authored-By: Claude Opus 4.5 <noreply@anthropic.com>
</commit_message>
<xml_diff>
--- a/examples/introduction.pptx
+++ b/examples/introduction.pptx
@@ -20,9 +20,10 @@
     <p:sldId id="268" r:id="rId14"/>
     <p:sldId id="269" r:id="rId15"/>
     <p:sldId id="270" r:id="rId16"/>
+    <p:sldId id="271" r:id="rId17"/>
   </p:sldIdLst>
   <p:notesMasterIdLst>
-    <p:notesMasterId r:id="rId17"/>
+    <p:notesMasterId r:id="rId18"/>
   </p:notesMasterIdLst>
   <p:sldSz cx="12192000" cy="6858000"/>
   <p:notesSz cx="6858000" cy="12192000"/>
@@ -1068,6 +1069,94 @@
             <a:fld id="{F7021451-1387-4CA6-816F-3879F97B5CBC}" type="slidenum">
               <a:rPr lang="en-US"/>
               <a:t>15</a:t>
+            </a:fld>
+            <a:endParaRPr lang="en-US"/>
+          </a:p>
+        </p:txBody>
+      </p:sp>
+    </p:spTree>
+    <p:extLst>
+      <p:ext uri="{BB962C8B-B14F-4D97-AF65-F5344CB8AC3E}">
+        <p14:creationId xmlns:p14="http://schemas.microsoft.com/office/powerpoint/2010/main" val="1024086991"/>
+      </p:ext>
+    </p:extLst>
+  </p:cSld>
+  <p:clrMapOvr>
+    <a:masterClrMapping/>
+  </p:clrMapOvr>
+</p:notes>
+</file>
+
+<file path=ppt/notesSlides/notesSlide16.xml><?xml version="1.0" encoding="utf-8"?>
+<p:notes xmlns:a="http://schemas.openxmlformats.org/drawingml/2006/main" xmlns:r="http://schemas.openxmlformats.org/officeDocument/2006/relationships" xmlns:p="http://schemas.openxmlformats.org/presentationml/2006/main">
+  <p:cSld>
+    <p:spTree>
+      <p:nvGrpSpPr>
+        <p:cNvPr id="1" name=""/>
+        <p:cNvGrpSpPr/>
+        <p:nvPr/>
+      </p:nvGrpSpPr>
+      <p:grpSpPr>
+        <a:xfrm>
+          <a:off x="0" y="0"/>
+          <a:ext cx="0" cy="0"/>
+          <a:chOff x="0" y="0"/>
+          <a:chExt cx="0" cy="0"/>
+        </a:xfrm>
+      </p:grpSpPr>
+      <p:sp>
+        <p:nvSpPr>
+          <p:cNvPr id="2" name="Slide Image Placeholder 1"/>
+          <p:cNvSpPr>
+            <a:spLocks noGrp="1" noRot="1" noChangeAspect="1"/>
+          </p:cNvSpPr>
+          <p:nvPr>
+            <p:ph type="sldImg"/>
+          </p:nvPr>
+        </p:nvSpPr>
+        <p:spPr/>
+      </p:sp>
+      <p:sp>
+        <p:nvSpPr>
+          <p:cNvPr id="3" name="Notes Placeholder 2"/>
+          <p:cNvSpPr>
+            <a:spLocks noGrp="1"/>
+          </p:cNvSpPr>
+          <p:nvPr>
+            <p:ph type="body" idx="1"/>
+          </p:nvPr>
+        </p:nvSpPr>
+        <p:spPr/>
+        <p:txBody>
+          <a:bodyPr/>
+          <a:lstStyle/>
+          <a:p>
+            <a:r>
+              <a:rPr lang="en-US" dirty="0"/>
+              <a:t/>
+            </a:r>
+            <a:endParaRPr lang="en-US" dirty="0"/>
+          </a:p>
+        </p:txBody>
+      </p:sp>
+      <p:sp>
+        <p:nvSpPr>
+          <p:cNvPr id="4" name="Slide Number Placeholder 3"/>
+          <p:cNvSpPr>
+            <a:spLocks noGrp="1"/>
+          </p:cNvSpPr>
+          <p:nvPr>
+            <p:ph type="sldNum" sz="quarter" idx="10"/>
+          </p:nvPr>
+        </p:nvSpPr>
+        <p:spPr/>
+        <p:txBody>
+          <a:bodyPr/>
+          <a:lstStyle/>
+          <a:p>
+            <a:fld id="{F7021451-1387-4CA6-816F-3879F97B5CBC}" type="slidenum">
+              <a:rPr lang="en-US"/>
+              <a:t>16</a:t>
             </a:fld>
             <a:endParaRPr lang="en-US"/>
           </a:p>
@@ -2122,8 +2211,8 @@
         </p:nvSpPr>
         <p:spPr>
           <a:xfrm>
-            <a:off x="457200" y="1645920"/>
-            <a:ext cx="11277295" cy="1828800"/>
+            <a:off x="621792" y="2871216"/>
+            <a:ext cx="7315200" cy="320040"/>
           </a:xfrm>
           <a:prstGeom prst="rect">
             <a:avLst/>
@@ -2135,14 +2224,72 @@
           <a:bodyPr wrap="square" rtlCol="0" anchor="ctr"/>
           <a:lstStyle/>
           <a:p>
-            <a:pPr algn="ctr" indent="0" marL="0">
+            <a:pPr indent="0" marL="0">
+              <a:buNone/>
+            </a:pPr>
+            <a:r>
+              <a:rPr lang="en-US" sz="1400" b="1" dirty="0">
+                <a:solidFill>
+                  <a:srgbClr val="7F7F7F"/>
+                </a:solidFill>
+                <a:latin typeface="メイリオ" pitchFamily="34" charset="0"/>
+                <a:ea typeface="メイリオ" pitchFamily="34" charset="-122"/>
+                <a:cs typeface="メイリオ" pitchFamily="34" charset="-120"/>
+              </a:rPr>
+              <a:t>スライド自動生成システム - </a:t>
+            </a:r>
+            <a:pPr indent="0" marL="0">
+              <a:buNone/>
+            </a:pPr>
+            <a:r>
+              <a:rPr lang="en-US" sz="1400" b="1" dirty="0">
+                <a:solidFill>
+                  <a:srgbClr val="EA4545"/>
+                </a:solidFill>
+                <a:uFill>
+                  <a:solidFill>
+                    <a:srgbClr val="CBC269"/>
+                  </a:solidFill>
+                </a:uFill>
+                <a:latin typeface="メイリオ" pitchFamily="34" charset="0"/>
+                <a:ea typeface="メイリオ" pitchFamily="34" charset="-122"/>
+                <a:cs typeface="メイリオ" pitchFamily="34" charset="-120"/>
+              </a:rPr>
+              <a:t>使い方ガイド</a:t>
+            </a:r>
+            <a:endParaRPr lang="en-US" sz="1400" dirty="0"/>
+          </a:p>
+        </p:txBody>
+      </p:sp>
+      <p:sp>
+        <p:nvSpPr>
+          <p:cNvPr id="3" name="Text 1"/>
+          <p:cNvSpPr/>
+          <p:nvPr/>
+        </p:nvSpPr>
+        <p:spPr>
+          <a:xfrm>
+            <a:off x="621792" y="3182112"/>
+            <a:ext cx="9144000" cy="731520"/>
+          </a:xfrm>
+          <a:prstGeom prst="rect">
+            <a:avLst/>
+          </a:prstGeom>
+          <a:noFill/>
+          <a:ln/>
+        </p:spPr>
+        <p:txBody>
+          <a:bodyPr wrap="square" rtlCol="0" anchor="ctr"/>
+          <a:lstStyle/>
+          <a:p>
+            <a:pPr indent="0" marL="0">
               <a:lnSpc>
-                <a:spcPts val="6000"/>
+                <a:spcPts val="3800"/>
               </a:lnSpc>
               <a:buNone/>
             </a:pPr>
             <a:r>
-              <a:rPr lang="en-US" sz="4000" b="1" dirty="0">
+              <a:rPr lang="en-US" sz="2400" b="1" dirty="0">
                 <a:solidFill>
                   <a:srgbClr val="454545"/>
                 </a:solidFill>
@@ -2150,66 +2297,29 @@
                 <a:ea typeface="メイリオ" pitchFamily="34" charset="-122"/>
                 <a:cs typeface="メイリオ" pitchFamily="34" charset="-120"/>
               </a:rPr>
-              <a:t>もうパワポ作成で</a:t>
-            </a:r>
-            <a:endParaRPr lang="en-US" sz="4000" dirty="0"/>
-          </a:p>
-          <a:p>
-            <a:pPr algn="ctr" indent="0" marL="0">
+              <a:t>AIを活用した  </a:t>
+            </a:r>
+            <a:pPr indent="0" marL="0">
               <a:lnSpc>
-                <a:spcPts val="6000"/>
+                <a:spcPts val="3800"/>
               </a:lnSpc>
               <a:buNone/>
             </a:pPr>
             <a:r>
-              <a:rPr lang="en-US" sz="4000" b="1" dirty="0">
+              <a:rPr lang="en-US" sz="3200" b="1" dirty="0">
                 <a:solidFill>
                   <a:srgbClr val="454545"/>
                 </a:solidFill>
-                <a:latin typeface="メイリオ" pitchFamily="34" charset="0"/>
-                <a:ea typeface="メイリオ" pitchFamily="34" charset="-122"/>
-                <a:cs typeface="メイリオ" pitchFamily="34" charset="-120"/>
-              </a:rPr>
-              <a:t>消耗するのはやめよう</a:t>
-            </a:r>
-            <a:endParaRPr lang="en-US" sz="4000" dirty="0"/>
-          </a:p>
-        </p:txBody>
-      </p:sp>
-      <p:sp>
-        <p:nvSpPr>
-          <p:cNvPr id="3" name="Text 1"/>
-          <p:cNvSpPr/>
-          <p:nvPr/>
-        </p:nvSpPr>
-        <p:spPr>
-          <a:xfrm>
-            <a:off x="457200" y="3840480"/>
-            <a:ext cx="11277295" cy="731520"/>
-          </a:xfrm>
-          <a:prstGeom prst="rect">
-            <a:avLst/>
-          </a:prstGeom>
-          <a:noFill/>
-          <a:ln/>
-        </p:spPr>
-        <p:txBody>
-          <a:bodyPr wrap="square" rtlCol="0" anchor="ctr"/>
-          <a:lstStyle/>
-          <a:p>
-            <a:pPr algn="ctr" indent="0" marL="0">
-              <a:buNone/>
-            </a:pPr>
-            <a:r>
-              <a:rPr lang="en-US" sz="2400" b="1" dirty="0">
-                <a:solidFill>
-                  <a:srgbClr val="CBC269"/>
-                </a:solidFill>
-                <a:latin typeface="メイリオ" pitchFamily="34" charset="0"/>
-                <a:ea typeface="メイリオ" pitchFamily="34" charset="-122"/>
-                <a:cs typeface="メイリオ" pitchFamily="34" charset="-120"/>
-              </a:rPr>
-              <a:t>PptxGenJS テンプレート で スライド作成を自動化</a:t>
+                <a:uFill>
+                  <a:solidFill>
+                    <a:srgbClr val="CBC269"/>
+                  </a:solidFill>
+                </a:uFill>
+                <a:latin typeface="メイリオ" pitchFamily="34" charset="0"/>
+                <a:ea typeface="メイリオ" pitchFamily="34" charset="-122"/>
+                <a:cs typeface="メイリオ" pitchFamily="34" charset="-120"/>
+              </a:rPr>
+              <a:t>PptxGenJS テンプレート</a:t>
             </a:r>
             <a:endParaRPr lang="en-US" sz="2400" dirty="0"/>
           </a:p>
@@ -2530,7 +2640,7 @@
                 <a:ea typeface="Consolas" pitchFamily="34" charset="-122"/>
                 <a:cs typeface="Consolas" pitchFamily="34" charset="-120"/>
               </a:rPr>
-              <a:t>addTitleSlide(pres, 'タイトル', 'サブタイトル');</a:t>
+              <a:t>// タイトルスライドを追加</a:t>
             </a:r>
             <a:endParaRPr lang="en-US" sz="1400" dirty="0"/>
           </a:p>
@@ -2547,7 +2657,7 @@
                 <a:ea typeface="Consolas" pitchFamily="34" charset="-122"/>
                 <a:cs typeface="Consolas" pitchFamily="34" charset="-120"/>
               </a:rPr>
-              <a:t>addContentSlide(pres, '見出し', ['ポイント1', 'ポイント2']);</a:t>
+              <a:t>addTitleSlide(pres, 'メインタイトル', 'サブ', '備考', 'ハイライト');</a:t>
             </a:r>
             <a:endParaRPr lang="en-US" sz="1400" dirty="0"/>
           </a:p>
@@ -2570,7 +2680,7 @@
                 <a:ea typeface="Consolas" pitchFamily="34" charset="-122"/>
                 <a:cs typeface="Consolas" pitchFamily="34" charset="-120"/>
               </a:rPr>
-              <a:t>pres.writeFile({ fileName: 'output.pptx' });</a:t>
+              <a:t>pres.writeFile({ fileName: 'output/presentation.pptx' });</a:t>
             </a:r>
             <a:endParaRPr lang="en-US" sz="1400" dirty="0"/>
           </a:p>
@@ -2712,7 +2822,7 @@
                 <a:ea typeface="メイリオ" pitchFamily="34" charset="-122"/>
                 <a:cs typeface="メイリオ" pitchFamily="34" charset="-120"/>
               </a:rPr>
-              <a:t>カスタマイズも自由自在</a:t>
+              <a:t>出力先フォルダについて</a:t>
             </a:r>
             <a:endParaRPr lang="en-US" sz="1400" dirty="0"/>
           </a:p>
@@ -2776,7 +2886,7 @@
                 <a:ea typeface="メイリオ" pitchFamily="34" charset="-122"/>
                 <a:cs typeface="メイリオ" pitchFamily="34" charset="-120"/>
               </a:rPr>
-              <a:t>theme.js を編集するだけ</a:t>
+              <a:t>output/ フォルダに出力すればリポジトリを汚さない</a:t>
             </a:r>
             <a:endParaRPr lang="en-US" sz="1600" dirty="0"/>
           </a:p>
@@ -2795,7 +2905,7 @@
                 <a:ea typeface="メイリオ" pitchFamily="34" charset="-122"/>
                 <a:cs typeface="メイリオ" pitchFamily="34" charset="-120"/>
               </a:rPr>
-              <a:t>カラーパレットを自社ブランドに変更可能</a:t>
+              <a:t>output/ は .gitignore で除外済み</a:t>
             </a:r>
             <a:endParaRPr lang="en-US" sz="1600" dirty="0"/>
           </a:p>
@@ -2814,7 +2924,7 @@
                 <a:ea typeface="メイリオ" pitchFamily="34" charset="-122"/>
                 <a:cs typeface="メイリオ" pitchFamily="34" charset="-120"/>
               </a:rPr>
-              <a:t>フォントも自由に設定</a:t>
+              <a:t>サンプルPPTXは template/ と examples/ に配置</a:t>
             </a:r>
             <a:endParaRPr lang="en-US" sz="1600" dirty="0"/>
           </a:p>
@@ -2833,26 +2943,7 @@
                 <a:ea typeface="メイリオ" pitchFamily="34" charset="-122"/>
                 <a:cs typeface="メイリオ" pitchFamily="34" charset="-120"/>
               </a:rPr>
-              <a:t>フッターの著作権表示もカンタン変更</a:t>
-            </a:r>
-            <a:endParaRPr lang="en-US" sz="1600" dirty="0"/>
-          </a:p>
-          <a:p>
-            <a:pPr>
-              <a:lnSpc>
-                <a:spcPts val="2400"/>
-              </a:lnSpc>
-            </a:pPr>
-            <a:r>
-              <a:rPr lang="en-US" sz="1600" b="1" dirty="0">
-                <a:solidFill>
-                  <a:srgbClr val="454545"/>
-                </a:solidFill>
-                <a:latin typeface="メイリオ" pitchFamily="34" charset="0"/>
-                <a:ea typeface="メイリオ" pitchFamily="34" charset="-122"/>
-                <a:cs typeface="メイリオ" pitchFamily="34" charset="-120"/>
-              </a:rPr>
-              <a:t>変更後は npm run generate-template で反映</a:t>
+              <a:t>新規作成時は output/ に保存を推奨</a:t>
             </a:r>
             <a:endParaRPr lang="en-US" sz="1600" dirty="0"/>
           </a:p>
@@ -2969,8 +3060,8 @@
         </p:nvSpPr>
         <p:spPr>
           <a:xfrm>
-            <a:off x="1188720" y="2286000"/>
-            <a:ext cx="9814255" cy="1828800"/>
+            <a:off x="0" y="91440"/>
+            <a:ext cx="12191695" cy="365760"/>
           </a:xfrm>
           <a:prstGeom prst="rect">
             <a:avLst/>
@@ -2986,7 +3077,7 @@
               <a:buNone/>
             </a:pPr>
             <a:r>
-              <a:rPr lang="en-US" sz="2400" i="1" dirty="0">
+              <a:rPr lang="en-US" sz="1400" b="1" dirty="0">
                 <a:solidFill>
                   <a:srgbClr val="454545"/>
                 </a:solidFill>
@@ -2994,26 +3085,9 @@
                 <a:ea typeface="メイリオ" pitchFamily="34" charset="-122"/>
                 <a:cs typeface="メイリオ" pitchFamily="34" charset="-120"/>
               </a:rPr>
-              <a:t>パワポ作成が苦痛だった過去の自分に教えてあげたい。</a:t>
-            </a:r>
-            <a:endParaRPr lang="en-US" sz="2400" dirty="0"/>
-          </a:p>
-          <a:p>
-            <a:pPr algn="ctr" indent="0" marL="0">
-              <a:buNone/>
-            </a:pPr>
-            <a:r>
-              <a:rPr lang="en-US" sz="2400" i="1" dirty="0">
-                <a:solidFill>
-                  <a:srgbClr val="454545"/>
-                </a:solidFill>
-                <a:latin typeface="メイリオ" pitchFamily="34" charset="0"/>
-                <a:ea typeface="メイリオ" pitchFamily="34" charset="-122"/>
-                <a:cs typeface="メイリオ" pitchFamily="34" charset="-120"/>
-              </a:rPr>
-              <a:t>このテンプレートがあれば、もっと早く帰れたのに。</a:t>
-            </a:r>
-            <a:endParaRPr lang="en-US" sz="2400" dirty="0"/>
+              <a:t>カスタマイズも自由自在</a:t>
+            </a:r>
+            <a:endParaRPr lang="en-US" sz="1400" dirty="0"/>
           </a:p>
         </p:txBody>
       </p:sp>
@@ -3025,14 +3099,14 @@
         </p:nvSpPr>
         <p:spPr>
           <a:xfrm>
-            <a:off x="4724248" y="4389120"/>
-            <a:ext cx="2743200" cy="0"/>
+            <a:off x="2849728" y="475488"/>
+            <a:ext cx="6492240" cy="0"/>
           </a:xfrm>
           <a:prstGeom prst="line">
             <a:avLst/>
           </a:prstGeom>
           <a:noFill/>
-          <a:ln w="25400">
+          <a:ln w="15875">
             <a:solidFill>
               <a:srgbClr val="CBC269"/>
             </a:solidFill>
@@ -3048,32 +3122,110 @@
         </p:nvSpPr>
         <p:spPr>
           <a:xfrm>
-            <a:off x="731520" y="4572000"/>
-            <a:ext cx="10728655" cy="457200"/>
-          </a:xfrm>
-          <a:prstGeom prst="rect">
-            <a:avLst/>
-          </a:prstGeom>
-          <a:noFill/>
-          <a:ln/>
-        </p:spPr>
-        <p:txBody>
-          <a:bodyPr wrap="square" rtlCol="0" anchor="ctr"/>
-          <a:lstStyle/>
-          <a:p>
-            <a:pPr algn="ctr" indent="0" marL="0">
-              <a:buNone/>
-            </a:pPr>
-            <a:r>
-              <a:rPr lang="en-US" sz="1600" dirty="0">
-                <a:solidFill>
-                  <a:srgbClr val="535353"/>
-                </a:solidFill>
-                <a:latin typeface="メイリオ" pitchFamily="34" charset="0"/>
-                <a:ea typeface="メイリオ" pitchFamily="34" charset="-122"/>
-                <a:cs typeface="メイリオ" pitchFamily="34" charset="-120"/>
-              </a:rPr>
-              <a:t>— とある開発者</a:t>
+            <a:off x="731520" y="1097280"/>
+            <a:ext cx="10728655" cy="4572000"/>
+          </a:xfrm>
+          <a:prstGeom prst="rect">
+            <a:avLst/>
+          </a:prstGeom>
+          <a:noFill/>
+          <a:ln/>
+        </p:spPr>
+        <p:txBody>
+          <a:bodyPr wrap="square" rtlCol="0" anchor="t"/>
+          <a:lstStyle/>
+          <a:p>
+            <a:pPr>
+              <a:lnSpc>
+                <a:spcPts val="2400"/>
+              </a:lnSpc>
+            </a:pPr>
+            <a:r>
+              <a:rPr lang="en-US" sz="1600" b="1" dirty="0">
+                <a:solidFill>
+                  <a:srgbClr val="454545"/>
+                </a:solidFill>
+                <a:latin typeface="メイリオ" pitchFamily="34" charset="0"/>
+                <a:ea typeface="メイリオ" pitchFamily="34" charset="-122"/>
+                <a:cs typeface="メイリオ" pitchFamily="34" charset="-120"/>
+              </a:rPr>
+              <a:t>theme.js を編集するだけ</a:t>
+            </a:r>
+            <a:endParaRPr lang="en-US" sz="1600" dirty="0"/>
+          </a:p>
+          <a:p>
+            <a:pPr>
+              <a:lnSpc>
+                <a:spcPts val="2400"/>
+              </a:lnSpc>
+            </a:pPr>
+            <a:r>
+              <a:rPr lang="en-US" sz="1600" b="1" dirty="0">
+                <a:solidFill>
+                  <a:srgbClr val="454545"/>
+                </a:solidFill>
+                <a:latin typeface="メイリオ" pitchFamily="34" charset="0"/>
+                <a:ea typeface="メイリオ" pitchFamily="34" charset="-122"/>
+                <a:cs typeface="メイリオ" pitchFamily="34" charset="-120"/>
+              </a:rPr>
+              <a:t>カラーパレットを自社ブランドに変更可能</a:t>
+            </a:r>
+            <a:endParaRPr lang="en-US" sz="1600" dirty="0"/>
+          </a:p>
+          <a:p>
+            <a:pPr>
+              <a:lnSpc>
+                <a:spcPts val="2400"/>
+              </a:lnSpc>
+            </a:pPr>
+            <a:r>
+              <a:rPr lang="en-US" sz="1600" b="1" dirty="0">
+                <a:solidFill>
+                  <a:srgbClr val="454545"/>
+                </a:solidFill>
+                <a:latin typeface="メイリオ" pitchFamily="34" charset="0"/>
+                <a:ea typeface="メイリオ" pitchFamily="34" charset="-122"/>
+                <a:cs typeface="メイリオ" pitchFamily="34" charset="-120"/>
+              </a:rPr>
+              <a:t>フォントも自由に設定</a:t>
+            </a:r>
+            <a:endParaRPr lang="en-US" sz="1600" dirty="0"/>
+          </a:p>
+          <a:p>
+            <a:pPr>
+              <a:lnSpc>
+                <a:spcPts val="2400"/>
+              </a:lnSpc>
+            </a:pPr>
+            <a:r>
+              <a:rPr lang="en-US" sz="1600" b="1" dirty="0">
+                <a:solidFill>
+                  <a:srgbClr val="454545"/>
+                </a:solidFill>
+                <a:latin typeface="メイリオ" pitchFamily="34" charset="0"/>
+                <a:ea typeface="メイリオ" pitchFamily="34" charset="-122"/>
+                <a:cs typeface="メイリオ" pitchFamily="34" charset="-120"/>
+              </a:rPr>
+              <a:t>フッターの著作権表示もカンタン変更</a:t>
+            </a:r>
+            <a:endParaRPr lang="en-US" sz="1600" dirty="0"/>
+          </a:p>
+          <a:p>
+            <a:pPr>
+              <a:lnSpc>
+                <a:spcPts val="2400"/>
+              </a:lnSpc>
+            </a:pPr>
+            <a:r>
+              <a:rPr lang="en-US" sz="1600" b="1" dirty="0">
+                <a:solidFill>
+                  <a:srgbClr val="454545"/>
+                </a:solidFill>
+                <a:latin typeface="メイリオ" pitchFamily="34" charset="0"/>
+                <a:ea typeface="メイリオ" pitchFamily="34" charset="-122"/>
+                <a:cs typeface="メイリオ" pitchFamily="34" charset="-120"/>
+              </a:rPr>
+              <a:t>変更後は npm run generate-template で反映</a:t>
             </a:r>
             <a:endParaRPr lang="en-US" sz="1600" dirty="0"/>
           </a:p>
@@ -3184,20 +3336,76 @@
       </p:grpSpPr>
       <p:sp>
         <p:nvSpPr>
-          <p:cNvPr id="2" name="Shape 0"/>
-          <p:cNvSpPr/>
-          <p:nvPr/>
-        </p:nvSpPr>
-        <p:spPr>
-          <a:xfrm>
-            <a:off x="2849728" y="475488"/>
-            <a:ext cx="6492240" cy="0"/>
+          <p:cNvPr id="2" name="Text 0"/>
+          <p:cNvSpPr/>
+          <p:nvPr/>
+        </p:nvSpPr>
+        <p:spPr>
+          <a:xfrm>
+            <a:off x="1188720" y="2286000"/>
+            <a:ext cx="9814255" cy="1828800"/>
+          </a:xfrm>
+          <a:prstGeom prst="rect">
+            <a:avLst/>
+          </a:prstGeom>
+          <a:noFill/>
+          <a:ln/>
+        </p:spPr>
+        <p:txBody>
+          <a:bodyPr wrap="square" rtlCol="0" anchor="ctr"/>
+          <a:lstStyle/>
+          <a:p>
+            <a:pPr algn="ctr" indent="0" marL="0">
+              <a:buNone/>
+            </a:pPr>
+            <a:r>
+              <a:rPr lang="en-US" sz="2400" i="1" dirty="0">
+                <a:solidFill>
+                  <a:srgbClr val="454545"/>
+                </a:solidFill>
+                <a:latin typeface="メイリオ" pitchFamily="34" charset="0"/>
+                <a:ea typeface="メイリオ" pitchFamily="34" charset="-122"/>
+                <a:cs typeface="メイリオ" pitchFamily="34" charset="-120"/>
+              </a:rPr>
+              <a:t>パワポ作成が苦痛だった過去の自分に教えてあげたい。</a:t>
+            </a:r>
+            <a:endParaRPr lang="en-US" sz="2400" dirty="0"/>
+          </a:p>
+          <a:p>
+            <a:pPr algn="ctr" indent="0" marL="0">
+              <a:buNone/>
+            </a:pPr>
+            <a:r>
+              <a:rPr lang="en-US" sz="2400" i="1" dirty="0">
+                <a:solidFill>
+                  <a:srgbClr val="454545"/>
+                </a:solidFill>
+                <a:latin typeface="メイリオ" pitchFamily="34" charset="0"/>
+                <a:ea typeface="メイリオ" pitchFamily="34" charset="-122"/>
+                <a:cs typeface="メイリオ" pitchFamily="34" charset="-120"/>
+              </a:rPr>
+              <a:t>このテンプレートがあれば、もっと早く帰れたのに。</a:t>
+            </a:r>
+            <a:endParaRPr lang="en-US" sz="2400" dirty="0"/>
+          </a:p>
+        </p:txBody>
+      </p:sp>
+      <p:sp>
+        <p:nvSpPr>
+          <p:cNvPr id="3" name="Shape 1"/>
+          <p:cNvSpPr/>
+          <p:nvPr/>
+        </p:nvSpPr>
+        <p:spPr>
+          <a:xfrm>
+            <a:off x="4724248" y="4389120"/>
+            <a:ext cx="2743200" cy="0"/>
           </a:xfrm>
           <a:prstGeom prst="line">
             <a:avLst/>
           </a:prstGeom>
           <a:noFill/>
-          <a:ln w="15875">
+          <a:ln w="25400">
             <a:solidFill>
               <a:srgbClr val="CBC269"/>
             </a:solidFill>
@@ -3207,14 +3415,14 @@
       </p:sp>
       <p:sp>
         <p:nvSpPr>
-          <p:cNvPr id="3" name="Text 1"/>
-          <p:cNvSpPr/>
-          <p:nvPr/>
-        </p:nvSpPr>
-        <p:spPr>
-          <a:xfrm>
-            <a:off x="0" y="91440"/>
-            <a:ext cx="12191695" cy="365760"/>
+          <p:cNvPr id="4" name="Text 2"/>
+          <p:cNvSpPr/>
+          <p:nvPr/>
+        </p:nvSpPr>
+        <p:spPr>
+          <a:xfrm>
+            <a:off x="731520" y="4572000"/>
+            <a:ext cx="10728655" cy="457200"/>
           </a:xfrm>
           <a:prstGeom prst="rect">
             <a:avLst/>
@@ -3230,144 +3438,17 @@
               <a:buNone/>
             </a:pPr>
             <a:r>
-              <a:rPr lang="en-US" sz="1400" b="1" dirty="0">
-                <a:solidFill>
-                  <a:srgbClr val="454545"/>
-                </a:solidFill>
-                <a:latin typeface="メイリオ" pitchFamily="34" charset="0"/>
-                <a:ea typeface="メイリオ" pitchFamily="34" charset="-122"/>
-                <a:cs typeface="メイリオ" pitchFamily="34" charset="-120"/>
-              </a:rPr>
-              <a:t>まとめ</a:t>
-            </a:r>
-            <a:endParaRPr lang="en-US" sz="1400" dirty="0"/>
-          </a:p>
-        </p:txBody>
-      </p:sp>
-      <p:sp>
-        <p:nvSpPr>
-          <p:cNvPr id="4" name="Text 2"/>
-          <p:cNvSpPr/>
-          <p:nvPr/>
-        </p:nvSpPr>
-        <p:spPr>
-          <a:xfrm>
-            <a:off x="1371600" y="1097280"/>
-            <a:ext cx="9448495" cy="4114800"/>
-          </a:xfrm>
-          <a:prstGeom prst="rect">
-            <a:avLst/>
-          </a:prstGeom>
-          <a:noFill/>
-          <a:ln/>
-        </p:spPr>
-        <p:txBody>
-          <a:bodyPr wrap="square" rtlCol="0" anchor="ctr"/>
-          <a:lstStyle/>
-          <a:p>
-            <a:pPr marL="342900" indent="-342900">
-              <a:lnSpc>
-                <a:spcPts val="3600"/>
-              </a:lnSpc>
-              <a:buSzPct val="100000"/>
-              <a:buChar char="✓"/>
-            </a:pPr>
-            <a:r>
-              <a:rPr lang="en-US" sz="2200" b="1" dirty="0">
-                <a:solidFill>
-                  <a:srgbClr val="454545"/>
-                </a:solidFill>
-                <a:latin typeface="メイリオ" pitchFamily="34" charset="0"/>
-                <a:ea typeface="メイリオ" pitchFamily="34" charset="-122"/>
-                <a:cs typeface="メイリオ" pitchFamily="34" charset="-120"/>
-              </a:rPr>
-              <a:t>Claude Code に話しかけるだけでスライド完成</a:t>
-            </a:r>
-            <a:endParaRPr lang="en-US" sz="2200" dirty="0"/>
-          </a:p>
-          <a:p>
-            <a:pPr marL="342900" indent="-342900">
-              <a:lnSpc>
-                <a:spcPts val="3600"/>
-              </a:lnSpc>
-              <a:buSzPct val="100000"/>
-              <a:buChar char="✓"/>
-            </a:pPr>
-            <a:r>
-              <a:rPr lang="en-US" sz="2200" b="1" dirty="0">
-                <a:solidFill>
-                  <a:srgbClr val="454545"/>
-                </a:solidFill>
-                <a:latin typeface="メイリオ" pitchFamily="34" charset="0"/>
-                <a:ea typeface="メイリオ" pitchFamily="34" charset="-122"/>
-                <a:cs typeface="メイリオ" pitchFamily="34" charset="-120"/>
-              </a:rPr>
-              <a:t>ブランドデザインが自動で統一される</a:t>
-            </a:r>
-            <a:endParaRPr lang="en-US" sz="2200" dirty="0"/>
-          </a:p>
-          <a:p>
-            <a:pPr marL="342900" indent="-342900">
-              <a:lnSpc>
-                <a:spcPts val="3600"/>
-              </a:lnSpc>
-              <a:buSzPct val="100000"/>
-              <a:buChar char="✓"/>
-            </a:pPr>
-            <a:r>
-              <a:rPr lang="en-US" sz="2200" b="1" dirty="0">
-                <a:solidFill>
-                  <a:srgbClr val="454545"/>
-                </a:solidFill>
-                <a:latin typeface="メイリオ" pitchFamily="34" charset="0"/>
-                <a:ea typeface="メイリオ" pitchFamily="34" charset="-122"/>
-                <a:cs typeface="メイリオ" pitchFamily="34" charset="-120"/>
-              </a:rPr>
-              <a:t>16種類のレイアウトですぐ使える</a:t>
-            </a:r>
-            <a:endParaRPr lang="en-US" sz="2200" dirty="0"/>
-          </a:p>
-          <a:p>
-            <a:pPr marL="342900" indent="-342900">
-              <a:lnSpc>
-                <a:spcPts val="3600"/>
-              </a:lnSpc>
-              <a:buSzPct val="100000"/>
-              <a:buChar char="✓"/>
-            </a:pPr>
-            <a:r>
-              <a:rPr lang="en-US" sz="2200" b="1" dirty="0">
-                <a:solidFill>
-                  <a:srgbClr val="454545"/>
-                </a:solidFill>
-                <a:latin typeface="メイリオ" pitchFamily="34" charset="0"/>
-                <a:ea typeface="メイリオ" pitchFamily="34" charset="-122"/>
-                <a:cs typeface="メイリオ" pitchFamily="34" charset="-120"/>
-              </a:rPr>
-              <a:t>セットアップは npm install だけ</a:t>
-            </a:r>
-            <a:endParaRPr lang="en-US" sz="2200" dirty="0"/>
-          </a:p>
-          <a:p>
-            <a:pPr marL="342900" indent="-342900">
-              <a:lnSpc>
-                <a:spcPts val="3600"/>
-              </a:lnSpc>
-              <a:buSzPct val="100000"/>
-              <a:buChar char="✓"/>
-            </a:pPr>
-            <a:r>
-              <a:rPr lang="en-US" sz="2200" b="1" dirty="0">
-                <a:solidFill>
-                  <a:srgbClr val="454545"/>
-                </a:solidFill>
-                <a:latin typeface="メイリオ" pitchFamily="34" charset="0"/>
-                <a:ea typeface="メイリオ" pitchFamily="34" charset="-122"/>
-                <a:cs typeface="メイリオ" pitchFamily="34" charset="-120"/>
-              </a:rPr>
-              <a:t>カスタマイズも theme.js を編集するだけ</a:t>
-            </a:r>
-            <a:endParaRPr lang="en-US" sz="2200" dirty="0"/>
+              <a:rPr lang="en-US" sz="1600" dirty="0">
+                <a:solidFill>
+                  <a:srgbClr val="535353"/>
+                </a:solidFill>
+                <a:latin typeface="メイリオ" pitchFamily="34" charset="0"/>
+                <a:ea typeface="メイリオ" pitchFamily="34" charset="-122"/>
+                <a:cs typeface="メイリオ" pitchFamily="34" charset="-120"/>
+              </a:rPr>
+              <a:t>— とある開発者</a:t>
+            </a:r>
+            <a:endParaRPr lang="en-US" sz="1600" dirty="0"/>
           </a:p>
         </p:txBody>
       </p:sp>
@@ -3482,16 +3563,19 @@
         </p:nvSpPr>
         <p:spPr>
           <a:xfrm>
-            <a:off x="0" y="0"/>
-            <a:ext cx="12191695" cy="6858000"/>
-          </a:xfrm>
-          <a:prstGeom prst="rect">
-            <a:avLst/>
-          </a:prstGeom>
-          <a:solidFill>
-            <a:srgbClr val="454545"/>
-          </a:solidFill>
-          <a:ln/>
+            <a:off x="2849728" y="475488"/>
+            <a:ext cx="6492240" cy="0"/>
+          </a:xfrm>
+          <a:prstGeom prst="line">
+            <a:avLst/>
+          </a:prstGeom>
+          <a:noFill/>
+          <a:ln w="15875">
+            <a:solidFill>
+              <a:srgbClr val="CBC269"/>
+            </a:solidFill>
+            <a:prstDash val="solid"/>
+          </a:ln>
         </p:spPr>
       </p:sp>
       <p:sp>
@@ -3502,8 +3586,8 @@
         </p:nvSpPr>
         <p:spPr>
           <a:xfrm>
-            <a:off x="457200" y="1828800"/>
-            <a:ext cx="11277295" cy="914400"/>
+            <a:off x="0" y="91440"/>
+            <a:ext cx="12191695" cy="365760"/>
           </a:xfrm>
           <a:prstGeom prst="rect">
             <a:avLst/>
@@ -3519,17 +3603,17 @@
               <a:buNone/>
             </a:pPr>
             <a:r>
-              <a:rPr lang="en-US" sz="4000" b="1" dirty="0">
-                <a:solidFill>
-                  <a:srgbClr val="FFFFFF"/>
-                </a:solidFill>
-                <a:latin typeface="メイリオ" pitchFamily="34" charset="0"/>
-                <a:ea typeface="メイリオ" pitchFamily="34" charset="-122"/>
-                <a:cs typeface="メイリオ" pitchFamily="34" charset="-120"/>
-              </a:rPr>
-              <a:t>今すぐ試してみよう</a:t>
-            </a:r>
-            <a:endParaRPr lang="en-US" sz="4000" dirty="0"/>
+              <a:rPr lang="en-US" sz="1400" b="1" dirty="0">
+                <a:solidFill>
+                  <a:srgbClr val="454545"/>
+                </a:solidFill>
+                <a:latin typeface="メイリオ" pitchFamily="34" charset="0"/>
+                <a:ea typeface="メイリオ" pitchFamily="34" charset="-122"/>
+                <a:cs typeface="メイリオ" pitchFamily="34" charset="-120"/>
+              </a:rPr>
+              <a:t>まとめ</a:t>
+            </a:r>
+            <a:endParaRPr lang="en-US" sz="1400" dirty="0"/>
           </a:p>
         </p:txBody>
       </p:sp>
@@ -3541,8 +3625,8 @@
         </p:nvSpPr>
         <p:spPr>
           <a:xfrm>
-            <a:off x="457200" y="3017520"/>
-            <a:ext cx="11277295" cy="731520"/>
+            <a:off x="1371600" y="1097280"/>
+            <a:ext cx="9448495" cy="4114800"/>
           </a:xfrm>
           <a:prstGeom prst="rect">
             <a:avLst/>
@@ -3554,34 +3638,161 @@
           <a:bodyPr wrap="square" rtlCol="0" anchor="ctr"/>
           <a:lstStyle/>
           <a:p>
-            <a:pPr algn="ctr" indent="0" marL="0">
-              <a:buNone/>
-            </a:pPr>
-            <a:r>
-              <a:rPr lang="en-US" sz="2800" b="1" dirty="0">
-                <a:solidFill>
-                  <a:srgbClr val="CBC269"/>
+            <a:pPr marL="342900" indent="-342900">
+              <a:lnSpc>
+                <a:spcPts val="3600"/>
+              </a:lnSpc>
+              <a:buSzPct val="100000"/>
+              <a:buChar char="✓"/>
+            </a:pPr>
+            <a:r>
+              <a:rPr lang="en-US" sz="2200" b="1" dirty="0">
+                <a:solidFill>
+                  <a:srgbClr val="454545"/>
+                </a:solidFill>
+                <a:latin typeface="メイリオ" pitchFamily="34" charset="0"/>
+                <a:ea typeface="メイリオ" pitchFamily="34" charset="-122"/>
+                <a:cs typeface="メイリオ" pitchFamily="34" charset="-120"/>
+              </a:rPr>
+              <a:t>Claude Code に話しかけるだけでスライド完成</a:t>
+            </a:r>
+            <a:endParaRPr lang="en-US" sz="2200" dirty="0"/>
+          </a:p>
+          <a:p>
+            <a:pPr marL="342900" indent="-342900">
+              <a:lnSpc>
+                <a:spcPts val="3600"/>
+              </a:lnSpc>
+              <a:buSzPct val="100000"/>
+              <a:buChar char="✓"/>
+            </a:pPr>
+            <a:r>
+              <a:rPr lang="en-US" sz="2200" b="1" dirty="0">
+                <a:solidFill>
+                  <a:srgbClr val="454545"/>
+                </a:solidFill>
+                <a:latin typeface="メイリオ" pitchFamily="34" charset="0"/>
+                <a:ea typeface="メイリオ" pitchFamily="34" charset="-122"/>
+                <a:cs typeface="メイリオ" pitchFamily="34" charset="-120"/>
+              </a:rPr>
+              <a:t>ブランドデザインが自動で統一される</a:t>
+            </a:r>
+            <a:endParaRPr lang="en-US" sz="2200" dirty="0"/>
+          </a:p>
+          <a:p>
+            <a:pPr marL="342900" indent="-342900">
+              <a:lnSpc>
+                <a:spcPts val="3600"/>
+              </a:lnSpc>
+              <a:buSzPct val="100000"/>
+              <a:buChar char="✓"/>
+            </a:pPr>
+            <a:r>
+              <a:rPr lang="en-US" sz="2200" b="1" dirty="0">
+                <a:solidFill>
+                  <a:srgbClr val="454545"/>
+                </a:solidFill>
+                <a:latin typeface="メイリオ" pitchFamily="34" charset="0"/>
+                <a:ea typeface="メイリオ" pitchFamily="34" charset="-122"/>
+                <a:cs typeface="メイリオ" pitchFamily="34" charset="-120"/>
+              </a:rPr>
+              <a:t>16種類のレイアウトですぐ使える</a:t>
+            </a:r>
+            <a:endParaRPr lang="en-US" sz="2200" dirty="0"/>
+          </a:p>
+          <a:p>
+            <a:pPr marL="342900" indent="-342900">
+              <a:lnSpc>
+                <a:spcPts val="3600"/>
+              </a:lnSpc>
+              <a:buSzPct val="100000"/>
+              <a:buChar char="✓"/>
+            </a:pPr>
+            <a:r>
+              <a:rPr lang="en-US" sz="2200" b="1" dirty="0">
+                <a:solidFill>
+                  <a:srgbClr val="454545"/>
+                </a:solidFill>
+                <a:latin typeface="メイリオ" pitchFamily="34" charset="0"/>
+                <a:ea typeface="メイリオ" pitchFamily="34" charset="-122"/>
+                <a:cs typeface="メイリオ" pitchFamily="34" charset="-120"/>
+              </a:rPr>
+              <a:t>セットアップは npm install だけ</a:t>
+            </a:r>
+            <a:endParaRPr lang="en-US" sz="2200" dirty="0"/>
+          </a:p>
+          <a:p>
+            <a:pPr marL="342900" indent="-342900">
+              <a:lnSpc>
+                <a:spcPts val="3600"/>
+              </a:lnSpc>
+              <a:buSzPct val="100000"/>
+              <a:buChar char="✓"/>
+            </a:pPr>
+            <a:r>
+              <a:rPr lang="en-US" sz="2200" b="1" dirty="0">
+                <a:solidFill>
+                  <a:srgbClr val="454545"/>
+                </a:solidFill>
+                <a:latin typeface="メイリオ" pitchFamily="34" charset="0"/>
+                <a:ea typeface="メイリオ" pitchFamily="34" charset="-122"/>
+                <a:cs typeface="メイリオ" pitchFamily="34" charset="-120"/>
+              </a:rPr>
+              <a:t>カスタマイズも theme.js を編集するだけ</a:t>
+            </a:r>
+            <a:endParaRPr lang="en-US" sz="2200" dirty="0"/>
+          </a:p>
+        </p:txBody>
+      </p:sp>
+      <p:sp>
+        <p:nvSpPr>
+          <p:cNvPr id="5" name="Text 3"/>
+          <p:cNvSpPr/>
+          <p:nvPr/>
+        </p:nvSpPr>
+        <p:spPr>
+          <a:xfrm>
+            <a:off x="155448" y="6537960"/>
+            <a:ext cx="1097280" cy="182880"/>
+          </a:xfrm>
+          <a:prstGeom prst="rect">
+            <a:avLst/>
+          </a:prstGeom>
+          <a:noFill/>
+          <a:ln/>
+        </p:spPr>
+        <p:txBody>
+          <a:bodyPr wrap="square" rtlCol="0" anchor="ctr"/>
+          <a:lstStyle/>
+          <a:p>
+            <a:pPr indent="0" marL="0">
+              <a:buNone/>
+            </a:pPr>
+            <a:r>
+              <a:rPr lang="en-US" sz="800" dirty="0">
+                <a:solidFill>
+                  <a:srgbClr val="ED6A5B"/>
                 </a:solidFill>
                 <a:latin typeface="Century Gothic" pitchFamily="34" charset="0"/>
                 <a:ea typeface="Century Gothic" pitchFamily="34" charset="-122"/>
                 <a:cs typeface="Century Gothic" pitchFamily="34" charset="-120"/>
               </a:rPr>
-              <a:t>git clone → npm install → 完了</a:t>
-            </a:r>
-            <a:endParaRPr lang="en-US" sz="2800" dirty="0"/>
-          </a:p>
-        </p:txBody>
-      </p:sp>
-      <p:sp>
-        <p:nvSpPr>
-          <p:cNvPr id="5" name="Text 3"/>
-          <p:cNvSpPr/>
-          <p:nvPr/>
-        </p:nvSpPr>
-        <p:spPr>
-          <a:xfrm>
-            <a:off x="457200" y="4114800"/>
-            <a:ext cx="11277295" cy="548640"/>
+              <a:t>Strictly Confidential</a:t>
+            </a:r>
+            <a:endParaRPr lang="en-US" sz="800" dirty="0"/>
+          </a:p>
+        </p:txBody>
+      </p:sp>
+      <p:sp>
+        <p:nvSpPr>
+          <p:cNvPr id="6" name="Text 4"/>
+          <p:cNvSpPr/>
+          <p:nvPr/>
+        </p:nvSpPr>
+        <p:spPr>
+          <a:xfrm>
+            <a:off x="4389120" y="6537960"/>
+            <a:ext cx="3657600" cy="182880"/>
           </a:xfrm>
           <a:prstGeom prst="rect">
             <a:avLst/>
@@ -3593,21 +3804,21 @@
           <a:bodyPr wrap="square" rtlCol="0" anchor="ctr"/>
           <a:lstStyle/>
           <a:p>
-            <a:pPr algn="ctr" indent="0" marL="0">
-              <a:buNone/>
-            </a:pPr>
-            <a:r>
-              <a:rPr lang="en-US" sz="2000" dirty="0">
-                <a:solidFill>
-                  <a:srgbClr val="7F7F7F"/>
-                </a:solidFill>
-                <a:latin typeface="メイリオ" pitchFamily="34" charset="0"/>
-                <a:ea typeface="メイリオ" pitchFamily="34" charset="-122"/>
-                <a:cs typeface="メイリオ" pitchFamily="34" charset="-120"/>
-              </a:rPr>
-              <a:t>あなたのパワポ作成ライフが変わります</a:t>
-            </a:r>
-            <a:endParaRPr lang="en-US" sz="2000" dirty="0"/>
+            <a:pPr algn="r" indent="0" marL="0">
+              <a:buNone/>
+            </a:pPr>
+            <a:r>
+              <a:rPr lang="en-US" sz="800" dirty="0">
+                <a:solidFill>
+                  <a:srgbClr val="535353"/>
+                </a:solidFill>
+                <a:latin typeface="Meiryo UI" pitchFamily="34" charset="0"/>
+                <a:ea typeface="Meiryo UI" pitchFamily="34" charset="-122"/>
+                <a:cs typeface="Meiryo UI" pitchFamily="34" charset="-120"/>
+              </a:rPr>
+              <a:t>Copyright © 2026 SBI Traceability co., Ltd. All Rights Reserved</a:t>
+            </a:r>
+            <a:endParaRPr lang="en-US" sz="800" dirty="0"/>
           </a:p>
         </p:txBody>
       </p:sp>
@@ -3638,6 +3849,168 @@
       </p:grpSpPr>
       <p:sp>
         <p:nvSpPr>
+          <p:cNvPr id="2" name="Shape 0"/>
+          <p:cNvSpPr/>
+          <p:nvPr/>
+        </p:nvSpPr>
+        <p:spPr>
+          <a:xfrm>
+            <a:off x="0" y="0"/>
+            <a:ext cx="12191695" cy="6858000"/>
+          </a:xfrm>
+          <a:prstGeom prst="rect">
+            <a:avLst/>
+          </a:prstGeom>
+          <a:solidFill>
+            <a:srgbClr val="454545"/>
+          </a:solidFill>
+          <a:ln/>
+        </p:spPr>
+      </p:sp>
+      <p:sp>
+        <p:nvSpPr>
+          <p:cNvPr id="3" name="Text 1"/>
+          <p:cNvSpPr/>
+          <p:nvPr/>
+        </p:nvSpPr>
+        <p:spPr>
+          <a:xfrm>
+            <a:off x="457200" y="1828800"/>
+            <a:ext cx="11277295" cy="914400"/>
+          </a:xfrm>
+          <a:prstGeom prst="rect">
+            <a:avLst/>
+          </a:prstGeom>
+          <a:noFill/>
+          <a:ln/>
+        </p:spPr>
+        <p:txBody>
+          <a:bodyPr wrap="square" rtlCol="0" anchor="ctr"/>
+          <a:lstStyle/>
+          <a:p>
+            <a:pPr algn="ctr" indent="0" marL="0">
+              <a:buNone/>
+            </a:pPr>
+            <a:r>
+              <a:rPr lang="en-US" sz="4000" b="1" dirty="0">
+                <a:solidFill>
+                  <a:srgbClr val="FFFFFF"/>
+                </a:solidFill>
+                <a:latin typeface="メイリオ" pitchFamily="34" charset="0"/>
+                <a:ea typeface="メイリオ" pitchFamily="34" charset="-122"/>
+                <a:cs typeface="メイリオ" pitchFamily="34" charset="-120"/>
+              </a:rPr>
+              <a:t>今すぐ試してみよう</a:t>
+            </a:r>
+            <a:endParaRPr lang="en-US" sz="4000" dirty="0"/>
+          </a:p>
+        </p:txBody>
+      </p:sp>
+      <p:sp>
+        <p:nvSpPr>
+          <p:cNvPr id="4" name="Text 2"/>
+          <p:cNvSpPr/>
+          <p:nvPr/>
+        </p:nvSpPr>
+        <p:spPr>
+          <a:xfrm>
+            <a:off x="457200" y="3017520"/>
+            <a:ext cx="11277295" cy="731520"/>
+          </a:xfrm>
+          <a:prstGeom prst="rect">
+            <a:avLst/>
+          </a:prstGeom>
+          <a:noFill/>
+          <a:ln/>
+        </p:spPr>
+        <p:txBody>
+          <a:bodyPr wrap="square" rtlCol="0" anchor="ctr"/>
+          <a:lstStyle/>
+          <a:p>
+            <a:pPr algn="ctr" indent="0" marL="0">
+              <a:buNone/>
+            </a:pPr>
+            <a:r>
+              <a:rPr lang="en-US" sz="2800" b="1" dirty="0">
+                <a:solidFill>
+                  <a:srgbClr val="CBC269"/>
+                </a:solidFill>
+                <a:latin typeface="Century Gothic" pitchFamily="34" charset="0"/>
+                <a:ea typeface="Century Gothic" pitchFamily="34" charset="-122"/>
+                <a:cs typeface="Century Gothic" pitchFamily="34" charset="-120"/>
+              </a:rPr>
+              <a:t>git clone → npm install → 完了</a:t>
+            </a:r>
+            <a:endParaRPr lang="en-US" sz="2800" dirty="0"/>
+          </a:p>
+        </p:txBody>
+      </p:sp>
+      <p:sp>
+        <p:nvSpPr>
+          <p:cNvPr id="5" name="Text 3"/>
+          <p:cNvSpPr/>
+          <p:nvPr/>
+        </p:nvSpPr>
+        <p:spPr>
+          <a:xfrm>
+            <a:off x="457200" y="4114800"/>
+            <a:ext cx="11277295" cy="548640"/>
+          </a:xfrm>
+          <a:prstGeom prst="rect">
+            <a:avLst/>
+          </a:prstGeom>
+          <a:noFill/>
+          <a:ln/>
+        </p:spPr>
+        <p:txBody>
+          <a:bodyPr wrap="square" rtlCol="0" anchor="ctr"/>
+          <a:lstStyle/>
+          <a:p>
+            <a:pPr algn="ctr" indent="0" marL="0">
+              <a:buNone/>
+            </a:pPr>
+            <a:r>
+              <a:rPr lang="en-US" sz="2000" dirty="0">
+                <a:solidFill>
+                  <a:srgbClr val="7F7F7F"/>
+                </a:solidFill>
+                <a:latin typeface="メイリオ" pitchFamily="34" charset="0"/>
+                <a:ea typeface="メイリオ" pitchFamily="34" charset="-122"/>
+                <a:cs typeface="メイリオ" pitchFamily="34" charset="-120"/>
+              </a:rPr>
+              <a:t>あなたのパワポ作成ライフが変わります</a:t>
+            </a:r>
+            <a:endParaRPr lang="en-US" sz="2000" dirty="0"/>
+          </a:p>
+        </p:txBody>
+      </p:sp>
+    </p:spTree>
+  </p:cSld>
+  <p:clrMapOvr>
+    <a:masterClrMapping/>
+  </p:clrMapOvr>
+</p:sld>
+</file>
+
+<file path=ppt/slides/slide16.xml><?xml version="1.0" encoding="utf-8"?>
+<p:sld xmlns:a="http://schemas.openxmlformats.org/drawingml/2006/main" xmlns:r="http://schemas.openxmlformats.org/officeDocument/2006/relationships" xmlns:p="http://schemas.openxmlformats.org/presentationml/2006/main">
+  <p:cSld name="Slide 16">
+    <p:spTree>
+      <p:nvGrpSpPr>
+        <p:cNvPr id="1" name=""/>
+        <p:cNvGrpSpPr/>
+        <p:nvPr/>
+      </p:nvGrpSpPr>
+      <p:grpSpPr>
+        <a:xfrm>
+          <a:off x="0" y="0"/>
+          <a:ext cx="0" cy="0"/>
+          <a:chOff x="0" y="0"/>
+          <a:chExt cx="0" cy="0"/>
+        </a:xfrm>
+      </p:grpSpPr>
+      <p:sp>
+        <p:nvSpPr>
           <p:cNvPr id="2" name="Text 0"/>
           <p:cNvSpPr/>
           <p:nvPr/>
@@ -6402,7 +6775,7 @@
                 <a:ea typeface="メイリオ" pitchFamily="34" charset="-122"/>
                 <a:cs typeface="メイリオ" pitchFamily="34" charset="-120"/>
               </a:rPr>
-              <a:t>16種類のレイアウトを用意</a:t>
+              <a:t>セットアップも超カンタン</a:t>
             </a:r>
             <a:endParaRPr lang="en-US" sz="1400" dirty="0"/>
           </a:p>
@@ -6433,131 +6806,57 @@
       </p:sp>
       <p:sp>
         <p:nvSpPr>
-          <p:cNvPr id="4" name="Text 2"/>
-          <p:cNvSpPr/>
-          <p:nvPr/>
-        </p:nvSpPr>
-        <p:spPr>
-          <a:xfrm>
-            <a:off x="731520" y="1097280"/>
-            <a:ext cx="10728655" cy="4572000"/>
-          </a:xfrm>
-          <a:prstGeom prst="rect">
-            <a:avLst/>
-          </a:prstGeom>
-          <a:noFill/>
-          <a:ln/>
-        </p:spPr>
-        <p:txBody>
-          <a:bodyPr wrap="square" rtlCol="0" anchor="t"/>
-          <a:lstStyle/>
-          <a:p>
-            <a:pPr>
-              <a:lnSpc>
-                <a:spcPts val="2400"/>
-              </a:lnSpc>
-            </a:pPr>
-            <a:r>
-              <a:rPr lang="en-US" sz="1600" b="1" dirty="0">
-                <a:solidFill>
-                  <a:srgbClr val="454545"/>
-                </a:solidFill>
-                <a:latin typeface="メイリオ" pitchFamily="34" charset="0"/>
-                <a:ea typeface="メイリオ" pitchFamily="34" charset="-122"/>
-                <a:cs typeface="メイリオ" pitchFamily="34" charset="-120"/>
-              </a:rPr>
-              <a:t>タイトル / セクション区切り / クロージング</a:t>
-            </a:r>
-            <a:endParaRPr lang="en-US" sz="1600" dirty="0"/>
-          </a:p>
-          <a:p>
-            <a:pPr>
-              <a:lnSpc>
-                <a:spcPts val="2400"/>
-              </a:lnSpc>
-            </a:pPr>
-            <a:r>
-              <a:rPr lang="en-US" sz="1600" b="1" dirty="0">
-                <a:solidFill>
-                  <a:srgbClr val="454545"/>
-                </a:solidFill>
-                <a:latin typeface="メイリオ" pitchFamily="34" charset="0"/>
-                <a:ea typeface="メイリオ" pitchFamily="34" charset="-122"/>
-                <a:cs typeface="メイリオ" pitchFamily="34" charset="-120"/>
-              </a:rPr>
-              <a:t>箇条書き / 2カラム / 3カラム</a:t>
-            </a:r>
-            <a:endParaRPr lang="en-US" sz="1600" dirty="0"/>
-          </a:p>
-          <a:p>
-            <a:pPr>
-              <a:lnSpc>
-                <a:spcPts val="2400"/>
-              </a:lnSpc>
-            </a:pPr>
-            <a:r>
-              <a:rPr lang="en-US" sz="1600" b="1" dirty="0">
-                <a:solidFill>
-                  <a:srgbClr val="454545"/>
-                </a:solidFill>
-                <a:latin typeface="メイリオ" pitchFamily="34" charset="0"/>
-                <a:ea typeface="メイリオ" pitchFamily="34" charset="-122"/>
-                <a:cs typeface="メイリオ" pitchFamily="34" charset="-120"/>
-              </a:rPr>
-              <a:t>KPIカード / タイムライン / Before-After比較</a:t>
-            </a:r>
-            <a:endParaRPr lang="en-US" sz="1600" dirty="0"/>
-          </a:p>
-          <a:p>
-            <a:pPr>
-              <a:lnSpc>
-                <a:spcPts val="2400"/>
-              </a:lnSpc>
-            </a:pPr>
-            <a:r>
-              <a:rPr lang="en-US" sz="1600" b="1" dirty="0">
-                <a:solidFill>
-                  <a:srgbClr val="454545"/>
-                </a:solidFill>
-                <a:latin typeface="メイリオ" pitchFamily="34" charset="0"/>
-                <a:ea typeface="メイリオ" pitchFamily="34" charset="-122"/>
-                <a:cs typeface="メイリオ" pitchFamily="34" charset="-120"/>
-              </a:rPr>
-              <a:t>アジェンダ / テーブル / 引用</a:t>
-            </a:r>
-            <a:endParaRPr lang="en-US" sz="1600" dirty="0"/>
-          </a:p>
-          <a:p>
-            <a:pPr>
-              <a:lnSpc>
-                <a:spcPts val="2400"/>
-              </a:lnSpc>
-            </a:pPr>
-            <a:r>
-              <a:rPr lang="en-US" sz="1600" b="1" dirty="0">
-                <a:solidFill>
-                  <a:srgbClr val="454545"/>
-                </a:solidFill>
-                <a:latin typeface="メイリオ" pitchFamily="34" charset="0"/>
-                <a:ea typeface="メイリオ" pitchFamily="34" charset="-122"/>
-                <a:cs typeface="メイリオ" pitchFamily="34" charset="-120"/>
-              </a:rPr>
-              <a:t>画像中央 / テキスト+図 / アイコングリッド / 強調</a:t>
-            </a:r>
-            <a:endParaRPr lang="en-US" sz="1600" dirty="0"/>
-          </a:p>
-        </p:txBody>
-      </p:sp>
-      <p:sp>
-        <p:nvSpPr>
-          <p:cNvPr id="5" name="Text 3"/>
-          <p:cNvSpPr/>
-          <p:nvPr/>
-        </p:nvSpPr>
-        <p:spPr>
-          <a:xfrm>
-            <a:off x="155448" y="6537960"/>
-            <a:ext cx="1097280" cy="182880"/>
+          <p:cNvPr id="4" name="Shape 2"/>
+          <p:cNvSpPr/>
+          <p:nvPr/>
+        </p:nvSpPr>
+        <p:spPr>
+          <a:xfrm>
+            <a:off x="2072602" y="2560320"/>
+            <a:ext cx="8046491" cy="0"/>
+          </a:xfrm>
+          <a:prstGeom prst="line">
+            <a:avLst/>
+          </a:prstGeom>
+          <a:noFill/>
+          <a:ln w="25400">
+            <a:solidFill>
+              <a:srgbClr val="CBC269"/>
+            </a:solidFill>
+            <a:prstDash val="solid"/>
+          </a:ln>
+        </p:spPr>
+      </p:sp>
+      <p:sp>
+        <p:nvSpPr>
+          <p:cNvPr id="5" name="Shape 3"/>
+          <p:cNvSpPr/>
+          <p:nvPr/>
+        </p:nvSpPr>
+        <p:spPr>
+          <a:xfrm>
+            <a:off x="1706842" y="2194560"/>
+            <a:ext cx="731520" cy="731520"/>
+          </a:xfrm>
+          <a:prstGeom prst="ellipse">
+            <a:avLst/>
+          </a:prstGeom>
+          <a:solidFill>
+            <a:srgbClr val="CBC269"/>
+          </a:solidFill>
+          <a:ln/>
+        </p:spPr>
+      </p:sp>
+      <p:sp>
+        <p:nvSpPr>
+          <p:cNvPr id="6" name="Text 4"/>
+          <p:cNvSpPr/>
+          <p:nvPr/>
+        </p:nvSpPr>
+        <p:spPr>
+          <a:xfrm>
+            <a:off x="1706842" y="2286000"/>
+            <a:ext cx="731520" cy="548640"/>
           </a:xfrm>
           <a:prstGeom prst="rect">
             <a:avLst/>
@@ -6569,18 +6868,546 @@
           <a:bodyPr wrap="square" rtlCol="0" anchor="ctr"/>
           <a:lstStyle/>
           <a:p>
-            <a:pPr indent="0" marL="0">
-              <a:buNone/>
-            </a:pPr>
-            <a:r>
-              <a:rPr lang="en-US" sz="800" dirty="0">
-                <a:solidFill>
-                  <a:srgbClr val="ED6A5B"/>
+            <a:pPr algn="ctr" indent="0" marL="0">
+              <a:buNone/>
+            </a:pPr>
+            <a:r>
+              <a:rPr lang="en-US" sz="2000" b="1" dirty="0">
+                <a:solidFill>
+                  <a:srgbClr val="FFFFFF"/>
                 </a:solidFill>
                 <a:latin typeface="Century Gothic" pitchFamily="34" charset="0"/>
                 <a:ea typeface="Century Gothic" pitchFamily="34" charset="-122"/>
                 <a:cs typeface="Century Gothic" pitchFamily="34" charset="-120"/>
               </a:rPr>
+              <a:t>1</a:t>
+            </a:r>
+            <a:endParaRPr lang="en-US" sz="2000" dirty="0"/>
+          </a:p>
+        </p:txBody>
+      </p:sp>
+      <p:sp>
+        <p:nvSpPr>
+          <p:cNvPr id="7" name="Text 5"/>
+          <p:cNvSpPr/>
+          <p:nvPr/>
+        </p:nvSpPr>
+        <p:spPr>
+          <a:xfrm>
+            <a:off x="822960" y="3108960"/>
+            <a:ext cx="2499284" cy="457200"/>
+          </a:xfrm>
+          <a:prstGeom prst="rect">
+            <a:avLst/>
+          </a:prstGeom>
+          <a:noFill/>
+          <a:ln/>
+        </p:spPr>
+        <p:txBody>
+          <a:bodyPr wrap="square" rtlCol="0" anchor="ctr"/>
+          <a:lstStyle/>
+          <a:p>
+            <a:pPr algn="ctr" indent="0" marL="0">
+              <a:buNone/>
+            </a:pPr>
+            <a:r>
+              <a:rPr lang="en-US" sz="1600" b="1" dirty="0">
+                <a:solidFill>
+                  <a:srgbClr val="454545"/>
+                </a:solidFill>
+                <a:latin typeface="メイリオ" pitchFamily="34" charset="0"/>
+                <a:ea typeface="メイリオ" pitchFamily="34" charset="-122"/>
+                <a:cs typeface="メイリオ" pitchFamily="34" charset="-120"/>
+              </a:rPr>
+              <a:t>Clone</a:t>
+            </a:r>
+            <a:endParaRPr lang="en-US" sz="1600" dirty="0"/>
+          </a:p>
+        </p:txBody>
+      </p:sp>
+      <p:sp>
+        <p:nvSpPr>
+          <p:cNvPr id="8" name="Text 6"/>
+          <p:cNvSpPr/>
+          <p:nvPr/>
+        </p:nvSpPr>
+        <p:spPr>
+          <a:xfrm>
+            <a:off x="822960" y="3566160"/>
+            <a:ext cx="2499284" cy="914400"/>
+          </a:xfrm>
+          <a:prstGeom prst="rect">
+            <a:avLst/>
+          </a:prstGeom>
+          <a:noFill/>
+          <a:ln/>
+        </p:spPr>
+        <p:txBody>
+          <a:bodyPr wrap="square" rtlCol="0" anchor="ctr"/>
+          <a:lstStyle/>
+          <a:p>
+            <a:pPr algn="ctr" indent="0" marL="0">
+              <a:buNone/>
+            </a:pPr>
+            <a:r>
+              <a:rPr lang="en-US" sz="1050" dirty="0">
+                <a:solidFill>
+                  <a:srgbClr val="535353"/>
+                </a:solidFill>
+                <a:latin typeface="メイリオ" pitchFamily="34" charset="0"/>
+                <a:ea typeface="メイリオ" pitchFamily="34" charset="-122"/>
+                <a:cs typeface="メイリオ" pitchFamily="34" charset="-120"/>
+              </a:rPr>
+              <a:t>リポジトリをクローン</a:t>
+            </a:r>
+            <a:endParaRPr lang="en-US" sz="1050" dirty="0"/>
+          </a:p>
+        </p:txBody>
+      </p:sp>
+      <p:sp>
+        <p:nvSpPr>
+          <p:cNvPr id="9" name="Shape 7"/>
+          <p:cNvSpPr/>
+          <p:nvPr/>
+        </p:nvSpPr>
+        <p:spPr>
+          <a:xfrm>
+            <a:off x="4389006" y="2194560"/>
+            <a:ext cx="731520" cy="731520"/>
+          </a:xfrm>
+          <a:prstGeom prst="ellipse">
+            <a:avLst/>
+          </a:prstGeom>
+          <a:solidFill>
+            <a:srgbClr val="CBC269"/>
+          </a:solidFill>
+          <a:ln/>
+        </p:spPr>
+      </p:sp>
+      <p:sp>
+        <p:nvSpPr>
+          <p:cNvPr id="10" name="Text 8"/>
+          <p:cNvSpPr/>
+          <p:nvPr/>
+        </p:nvSpPr>
+        <p:spPr>
+          <a:xfrm>
+            <a:off x="4389006" y="2286000"/>
+            <a:ext cx="731520" cy="548640"/>
+          </a:xfrm>
+          <a:prstGeom prst="rect">
+            <a:avLst/>
+          </a:prstGeom>
+          <a:noFill/>
+          <a:ln/>
+        </p:spPr>
+        <p:txBody>
+          <a:bodyPr wrap="square" rtlCol="0" anchor="ctr"/>
+          <a:lstStyle/>
+          <a:p>
+            <a:pPr algn="ctr" indent="0" marL="0">
+              <a:buNone/>
+            </a:pPr>
+            <a:r>
+              <a:rPr lang="en-US" sz="2000" b="1" dirty="0">
+                <a:solidFill>
+                  <a:srgbClr val="FFFFFF"/>
+                </a:solidFill>
+                <a:latin typeface="Century Gothic" pitchFamily="34" charset="0"/>
+                <a:ea typeface="Century Gothic" pitchFamily="34" charset="-122"/>
+                <a:cs typeface="Century Gothic" pitchFamily="34" charset="-120"/>
+              </a:rPr>
+              <a:t>2</a:t>
+            </a:r>
+            <a:endParaRPr lang="en-US" sz="2000" dirty="0"/>
+          </a:p>
+        </p:txBody>
+      </p:sp>
+      <p:sp>
+        <p:nvSpPr>
+          <p:cNvPr id="11" name="Text 9"/>
+          <p:cNvSpPr/>
+          <p:nvPr/>
+        </p:nvSpPr>
+        <p:spPr>
+          <a:xfrm>
+            <a:off x="3505124" y="3108960"/>
+            <a:ext cx="2499284" cy="457200"/>
+          </a:xfrm>
+          <a:prstGeom prst="rect">
+            <a:avLst/>
+          </a:prstGeom>
+          <a:noFill/>
+          <a:ln/>
+        </p:spPr>
+        <p:txBody>
+          <a:bodyPr wrap="square" rtlCol="0" anchor="ctr"/>
+          <a:lstStyle/>
+          <a:p>
+            <a:pPr algn="ctr" indent="0" marL="0">
+              <a:buNone/>
+            </a:pPr>
+            <a:r>
+              <a:rPr lang="en-US" sz="1600" b="1" dirty="0">
+                <a:solidFill>
+                  <a:srgbClr val="454545"/>
+                </a:solidFill>
+                <a:latin typeface="メイリオ" pitchFamily="34" charset="0"/>
+                <a:ea typeface="メイリオ" pitchFamily="34" charset="-122"/>
+                <a:cs typeface="メイリオ" pitchFamily="34" charset="-120"/>
+              </a:rPr>
+              <a:t>Install</a:t>
+            </a:r>
+            <a:endParaRPr lang="en-US" sz="1600" dirty="0"/>
+          </a:p>
+        </p:txBody>
+      </p:sp>
+      <p:sp>
+        <p:nvSpPr>
+          <p:cNvPr id="12" name="Text 10"/>
+          <p:cNvSpPr/>
+          <p:nvPr/>
+        </p:nvSpPr>
+        <p:spPr>
+          <a:xfrm>
+            <a:off x="3505124" y="3566160"/>
+            <a:ext cx="2499284" cy="914400"/>
+          </a:xfrm>
+          <a:prstGeom prst="rect">
+            <a:avLst/>
+          </a:prstGeom>
+          <a:noFill/>
+          <a:ln/>
+        </p:spPr>
+        <p:txBody>
+          <a:bodyPr wrap="square" rtlCol="0" anchor="ctr"/>
+          <a:lstStyle/>
+          <a:p>
+            <a:pPr algn="ctr" indent="0" marL="0">
+              <a:buNone/>
+            </a:pPr>
+            <a:r>
+              <a:rPr lang="en-US" sz="1050" dirty="0">
+                <a:solidFill>
+                  <a:srgbClr val="535353"/>
+                </a:solidFill>
+                <a:latin typeface="メイリオ" pitchFamily="34" charset="0"/>
+                <a:ea typeface="メイリオ" pitchFamily="34" charset="-122"/>
+                <a:cs typeface="メイリオ" pitchFamily="34" charset="-120"/>
+              </a:rPr>
+              <a:t>npm install</a:t>
+            </a:r>
+            <a:endParaRPr lang="en-US" sz="1050" dirty="0"/>
+          </a:p>
+        </p:txBody>
+      </p:sp>
+      <p:sp>
+        <p:nvSpPr>
+          <p:cNvPr id="13" name="Shape 11"/>
+          <p:cNvSpPr/>
+          <p:nvPr/>
+        </p:nvSpPr>
+        <p:spPr>
+          <a:xfrm>
+            <a:off x="7071169" y="2194560"/>
+            <a:ext cx="731520" cy="731520"/>
+          </a:xfrm>
+          <a:prstGeom prst="ellipse">
+            <a:avLst/>
+          </a:prstGeom>
+          <a:solidFill>
+            <a:srgbClr val="CBC269"/>
+          </a:solidFill>
+          <a:ln/>
+        </p:spPr>
+      </p:sp>
+      <p:sp>
+        <p:nvSpPr>
+          <p:cNvPr id="14" name="Text 12"/>
+          <p:cNvSpPr/>
+          <p:nvPr/>
+        </p:nvSpPr>
+        <p:spPr>
+          <a:xfrm>
+            <a:off x="7071169" y="2286000"/>
+            <a:ext cx="731520" cy="548640"/>
+          </a:xfrm>
+          <a:prstGeom prst="rect">
+            <a:avLst/>
+          </a:prstGeom>
+          <a:noFill/>
+          <a:ln/>
+        </p:spPr>
+        <p:txBody>
+          <a:bodyPr wrap="square" rtlCol="0" anchor="ctr"/>
+          <a:lstStyle/>
+          <a:p>
+            <a:pPr algn="ctr" indent="0" marL="0">
+              <a:buNone/>
+            </a:pPr>
+            <a:r>
+              <a:rPr lang="en-US" sz="2000" b="1" dirty="0">
+                <a:solidFill>
+                  <a:srgbClr val="FFFFFF"/>
+                </a:solidFill>
+                <a:latin typeface="Century Gothic" pitchFamily="34" charset="0"/>
+                <a:ea typeface="Century Gothic" pitchFamily="34" charset="-122"/>
+                <a:cs typeface="Century Gothic" pitchFamily="34" charset="-120"/>
+              </a:rPr>
+              <a:t>3</a:t>
+            </a:r>
+            <a:endParaRPr lang="en-US" sz="2000" dirty="0"/>
+          </a:p>
+        </p:txBody>
+      </p:sp>
+      <p:sp>
+        <p:nvSpPr>
+          <p:cNvPr id="15" name="Text 13"/>
+          <p:cNvSpPr/>
+          <p:nvPr/>
+        </p:nvSpPr>
+        <p:spPr>
+          <a:xfrm>
+            <a:off x="6187288" y="3108960"/>
+            <a:ext cx="2499284" cy="457200"/>
+          </a:xfrm>
+          <a:prstGeom prst="rect">
+            <a:avLst/>
+          </a:prstGeom>
+          <a:noFill/>
+          <a:ln/>
+        </p:spPr>
+        <p:txBody>
+          <a:bodyPr wrap="square" rtlCol="0" anchor="ctr"/>
+          <a:lstStyle/>
+          <a:p>
+            <a:pPr algn="ctr" indent="0" marL="0">
+              <a:buNone/>
+            </a:pPr>
+            <a:r>
+              <a:rPr lang="en-US" sz="1600" b="1" dirty="0">
+                <a:solidFill>
+                  <a:srgbClr val="454545"/>
+                </a:solidFill>
+                <a:latin typeface="メイリオ" pitchFamily="34" charset="0"/>
+                <a:ea typeface="メイリオ" pitchFamily="34" charset="-122"/>
+                <a:cs typeface="メイリオ" pitchFamily="34" charset="-120"/>
+              </a:rPr>
+              <a:t>Generate</a:t>
+            </a:r>
+            <a:endParaRPr lang="en-US" sz="1600" dirty="0"/>
+          </a:p>
+        </p:txBody>
+      </p:sp>
+      <p:sp>
+        <p:nvSpPr>
+          <p:cNvPr id="16" name="Text 14"/>
+          <p:cNvSpPr/>
+          <p:nvPr/>
+        </p:nvSpPr>
+        <p:spPr>
+          <a:xfrm>
+            <a:off x="6187288" y="3566160"/>
+            <a:ext cx="2499284" cy="914400"/>
+          </a:xfrm>
+          <a:prstGeom prst="rect">
+            <a:avLst/>
+          </a:prstGeom>
+          <a:noFill/>
+          <a:ln/>
+        </p:spPr>
+        <p:txBody>
+          <a:bodyPr wrap="square" rtlCol="0" anchor="ctr"/>
+          <a:lstStyle/>
+          <a:p>
+            <a:pPr algn="ctr" indent="0" marL="0">
+              <a:buNone/>
+            </a:pPr>
+            <a:r>
+              <a:rPr lang="en-US" sz="1050" dirty="0">
+                <a:solidFill>
+                  <a:srgbClr val="535353"/>
+                </a:solidFill>
+                <a:latin typeface="メイリオ" pitchFamily="34" charset="0"/>
+                <a:ea typeface="メイリオ" pitchFamily="34" charset="-122"/>
+                <a:cs typeface="メイリオ" pitchFamily="34" charset="-120"/>
+              </a:rPr>
+              <a:t>npm run generate-template</a:t>
+            </a:r>
+            <a:endParaRPr lang="en-US" sz="1050" dirty="0"/>
+          </a:p>
+        </p:txBody>
+      </p:sp>
+      <p:sp>
+        <p:nvSpPr>
+          <p:cNvPr id="17" name="Shape 15"/>
+          <p:cNvSpPr/>
+          <p:nvPr/>
+        </p:nvSpPr>
+        <p:spPr>
+          <a:xfrm>
+            <a:off x="9753333" y="2194560"/>
+            <a:ext cx="731520" cy="731520"/>
+          </a:xfrm>
+          <a:prstGeom prst="ellipse">
+            <a:avLst/>
+          </a:prstGeom>
+          <a:solidFill>
+            <a:srgbClr val="CBC269"/>
+          </a:solidFill>
+          <a:ln/>
+        </p:spPr>
+      </p:sp>
+      <p:sp>
+        <p:nvSpPr>
+          <p:cNvPr id="18" name="Text 16"/>
+          <p:cNvSpPr/>
+          <p:nvPr/>
+        </p:nvSpPr>
+        <p:spPr>
+          <a:xfrm>
+            <a:off x="9753333" y="2286000"/>
+            <a:ext cx="731520" cy="548640"/>
+          </a:xfrm>
+          <a:prstGeom prst="rect">
+            <a:avLst/>
+          </a:prstGeom>
+          <a:noFill/>
+          <a:ln/>
+        </p:spPr>
+        <p:txBody>
+          <a:bodyPr wrap="square" rtlCol="0" anchor="ctr"/>
+          <a:lstStyle/>
+          <a:p>
+            <a:pPr algn="ctr" indent="0" marL="0">
+              <a:buNone/>
+            </a:pPr>
+            <a:r>
+              <a:rPr lang="en-US" sz="2000" b="1" dirty="0">
+                <a:solidFill>
+                  <a:srgbClr val="FFFFFF"/>
+                </a:solidFill>
+                <a:latin typeface="Century Gothic" pitchFamily="34" charset="0"/>
+                <a:ea typeface="Century Gothic" pitchFamily="34" charset="-122"/>
+                <a:cs typeface="Century Gothic" pitchFamily="34" charset="-120"/>
+              </a:rPr>
+              <a:t>4</a:t>
+            </a:r>
+            <a:endParaRPr lang="en-US" sz="2000" dirty="0"/>
+          </a:p>
+        </p:txBody>
+      </p:sp>
+      <p:sp>
+        <p:nvSpPr>
+          <p:cNvPr id="19" name="Text 17"/>
+          <p:cNvSpPr/>
+          <p:nvPr/>
+        </p:nvSpPr>
+        <p:spPr>
+          <a:xfrm>
+            <a:off x="8869451" y="3108960"/>
+            <a:ext cx="2499284" cy="457200"/>
+          </a:xfrm>
+          <a:prstGeom prst="rect">
+            <a:avLst/>
+          </a:prstGeom>
+          <a:noFill/>
+          <a:ln/>
+        </p:spPr>
+        <p:txBody>
+          <a:bodyPr wrap="square" rtlCol="0" anchor="ctr"/>
+          <a:lstStyle/>
+          <a:p>
+            <a:pPr algn="ctr" indent="0" marL="0">
+              <a:buNone/>
+            </a:pPr>
+            <a:r>
+              <a:rPr lang="en-US" sz="1600" b="1" dirty="0">
+                <a:solidFill>
+                  <a:srgbClr val="454545"/>
+                </a:solidFill>
+                <a:latin typeface="メイリオ" pitchFamily="34" charset="0"/>
+                <a:ea typeface="メイリオ" pitchFamily="34" charset="-122"/>
+                <a:cs typeface="メイリオ" pitchFamily="34" charset="-120"/>
+              </a:rPr>
+              <a:t>Done!</a:t>
+            </a:r>
+            <a:endParaRPr lang="en-US" sz="1600" dirty="0"/>
+          </a:p>
+        </p:txBody>
+      </p:sp>
+      <p:sp>
+        <p:nvSpPr>
+          <p:cNvPr id="20" name="Text 18"/>
+          <p:cNvSpPr/>
+          <p:nvPr/>
+        </p:nvSpPr>
+        <p:spPr>
+          <a:xfrm>
+            <a:off x="8869451" y="3566160"/>
+            <a:ext cx="2499284" cy="914400"/>
+          </a:xfrm>
+          <a:prstGeom prst="rect">
+            <a:avLst/>
+          </a:prstGeom>
+          <a:noFill/>
+          <a:ln/>
+        </p:spPr>
+        <p:txBody>
+          <a:bodyPr wrap="square" rtlCol="0" anchor="ctr"/>
+          <a:lstStyle/>
+          <a:p>
+            <a:pPr algn="ctr" indent="0" marL="0">
+              <a:buNone/>
+            </a:pPr>
+            <a:r>
+              <a:rPr lang="en-US" sz="1050" dirty="0">
+                <a:solidFill>
+                  <a:srgbClr val="535353"/>
+                </a:solidFill>
+                <a:latin typeface="メイリオ" pitchFamily="34" charset="0"/>
+                <a:ea typeface="メイリオ" pitchFamily="34" charset="-122"/>
+                <a:cs typeface="メイリオ" pitchFamily="34" charset="-120"/>
+              </a:rPr>
+              <a:t>すぐ使える</a:t>
+            </a:r>
+            <a:endParaRPr lang="en-US" sz="1050" dirty="0"/>
+          </a:p>
+        </p:txBody>
+      </p:sp>
+      <p:sp>
+        <p:nvSpPr>
+          <p:cNvPr id="21" name="Text 19"/>
+          <p:cNvSpPr/>
+          <p:nvPr/>
+        </p:nvSpPr>
+        <p:spPr>
+          <a:xfrm>
+            <a:off x="155448" y="6537960"/>
+            <a:ext cx="1097280" cy="182880"/>
+          </a:xfrm>
+          <a:prstGeom prst="rect">
+            <a:avLst/>
+          </a:prstGeom>
+          <a:noFill/>
+          <a:ln/>
+        </p:spPr>
+        <p:txBody>
+          <a:bodyPr wrap="square" rtlCol="0" anchor="ctr"/>
+          <a:lstStyle/>
+          <a:p>
+            <a:pPr indent="0" marL="0">
+              <a:buNone/>
+            </a:pPr>
+            <a:r>
+              <a:rPr lang="en-US" sz="800" dirty="0">
+                <a:solidFill>
+                  <a:srgbClr val="ED6A5B"/>
+                </a:solidFill>
+                <a:latin typeface="Century Gothic" pitchFamily="34" charset="0"/>
+                <a:ea typeface="Century Gothic" pitchFamily="34" charset="-122"/>
+                <a:cs typeface="Century Gothic" pitchFamily="34" charset="-120"/>
+              </a:rPr>
               <a:t>Strictly Confidential</a:t>
             </a:r>
             <a:endParaRPr lang="en-US" sz="800" dirty="0"/>
@@ -6589,7 +7416,7 @@
       </p:sp>
       <p:sp>
         <p:nvSpPr>
-          <p:cNvPr id="6" name="Text 4"/>
+          <p:cNvPr id="22" name="Text 20"/>
           <p:cNvSpPr/>
           <p:nvPr/>
         </p:nvSpPr>
@@ -6684,7 +7511,7 @@
                 <a:ea typeface="メイリオ" pitchFamily="34" charset="-122"/>
                 <a:cs typeface="メイリオ" pitchFamily="34" charset="-120"/>
               </a:rPr>
-              <a:t>セットアップも超カンタン</a:t>
+              <a:t>16種類のレイアウトを用意</a:t>
             </a:r>
             <a:endParaRPr lang="en-US" sz="1400" dirty="0"/>
           </a:p>
@@ -6715,57 +7542,131 @@
       </p:sp>
       <p:sp>
         <p:nvSpPr>
-          <p:cNvPr id="4" name="Shape 2"/>
-          <p:cNvSpPr/>
-          <p:nvPr/>
-        </p:nvSpPr>
-        <p:spPr>
-          <a:xfrm>
-            <a:off x="2072602" y="2560320"/>
-            <a:ext cx="8046491" cy="0"/>
-          </a:xfrm>
-          <a:prstGeom prst="line">
-            <a:avLst/>
-          </a:prstGeom>
-          <a:noFill/>
-          <a:ln w="25400">
-            <a:solidFill>
-              <a:srgbClr val="CBC269"/>
-            </a:solidFill>
-            <a:prstDash val="solid"/>
-          </a:ln>
-        </p:spPr>
-      </p:sp>
-      <p:sp>
-        <p:nvSpPr>
-          <p:cNvPr id="5" name="Shape 3"/>
-          <p:cNvSpPr/>
-          <p:nvPr/>
-        </p:nvSpPr>
-        <p:spPr>
-          <a:xfrm>
-            <a:off x="1706842" y="2194560"/>
-            <a:ext cx="731520" cy="731520"/>
-          </a:xfrm>
-          <a:prstGeom prst="ellipse">
-            <a:avLst/>
-          </a:prstGeom>
-          <a:solidFill>
-            <a:srgbClr val="CBC269"/>
-          </a:solidFill>
-          <a:ln/>
-        </p:spPr>
-      </p:sp>
-      <p:sp>
-        <p:nvSpPr>
-          <p:cNvPr id="6" name="Text 4"/>
-          <p:cNvSpPr/>
-          <p:nvPr/>
-        </p:nvSpPr>
-        <p:spPr>
-          <a:xfrm>
-            <a:off x="1706842" y="2286000"/>
-            <a:ext cx="731520" cy="548640"/>
+          <p:cNvPr id="4" name="Text 2"/>
+          <p:cNvSpPr/>
+          <p:nvPr/>
+        </p:nvSpPr>
+        <p:spPr>
+          <a:xfrm>
+            <a:off x="731520" y="1097280"/>
+            <a:ext cx="10728655" cy="4572000"/>
+          </a:xfrm>
+          <a:prstGeom prst="rect">
+            <a:avLst/>
+          </a:prstGeom>
+          <a:noFill/>
+          <a:ln/>
+        </p:spPr>
+        <p:txBody>
+          <a:bodyPr wrap="square" rtlCol="0" anchor="t"/>
+          <a:lstStyle/>
+          <a:p>
+            <a:pPr>
+              <a:lnSpc>
+                <a:spcPts val="2400"/>
+              </a:lnSpc>
+            </a:pPr>
+            <a:r>
+              <a:rPr lang="en-US" sz="1600" b="1" dirty="0">
+                <a:solidFill>
+                  <a:srgbClr val="454545"/>
+                </a:solidFill>
+                <a:latin typeface="メイリオ" pitchFamily="34" charset="0"/>
+                <a:ea typeface="メイリオ" pitchFamily="34" charset="-122"/>
+                <a:cs typeface="メイリオ" pitchFamily="34" charset="-120"/>
+              </a:rPr>
+              <a:t>タイトル / セクション区切り / クロージング</a:t>
+            </a:r>
+            <a:endParaRPr lang="en-US" sz="1600" dirty="0"/>
+          </a:p>
+          <a:p>
+            <a:pPr>
+              <a:lnSpc>
+                <a:spcPts val="2400"/>
+              </a:lnSpc>
+            </a:pPr>
+            <a:r>
+              <a:rPr lang="en-US" sz="1600" b="1" dirty="0">
+                <a:solidFill>
+                  <a:srgbClr val="454545"/>
+                </a:solidFill>
+                <a:latin typeface="メイリオ" pitchFamily="34" charset="0"/>
+                <a:ea typeface="メイリオ" pitchFamily="34" charset="-122"/>
+                <a:cs typeface="メイリオ" pitchFamily="34" charset="-120"/>
+              </a:rPr>
+              <a:t>箇条書き / 2カラム / 3カラム</a:t>
+            </a:r>
+            <a:endParaRPr lang="en-US" sz="1600" dirty="0"/>
+          </a:p>
+          <a:p>
+            <a:pPr>
+              <a:lnSpc>
+                <a:spcPts val="2400"/>
+              </a:lnSpc>
+            </a:pPr>
+            <a:r>
+              <a:rPr lang="en-US" sz="1600" b="1" dirty="0">
+                <a:solidFill>
+                  <a:srgbClr val="454545"/>
+                </a:solidFill>
+                <a:latin typeface="メイリオ" pitchFamily="34" charset="0"/>
+                <a:ea typeface="メイリオ" pitchFamily="34" charset="-122"/>
+                <a:cs typeface="メイリオ" pitchFamily="34" charset="-120"/>
+              </a:rPr>
+              <a:t>KPIカード / タイムライン / Before-After比較</a:t>
+            </a:r>
+            <a:endParaRPr lang="en-US" sz="1600" dirty="0"/>
+          </a:p>
+          <a:p>
+            <a:pPr>
+              <a:lnSpc>
+                <a:spcPts val="2400"/>
+              </a:lnSpc>
+            </a:pPr>
+            <a:r>
+              <a:rPr lang="en-US" sz="1600" b="1" dirty="0">
+                <a:solidFill>
+                  <a:srgbClr val="454545"/>
+                </a:solidFill>
+                <a:latin typeface="メイリオ" pitchFamily="34" charset="0"/>
+                <a:ea typeface="メイリオ" pitchFamily="34" charset="-122"/>
+                <a:cs typeface="メイリオ" pitchFamily="34" charset="-120"/>
+              </a:rPr>
+              <a:t>アジェンダ / テーブル / 引用</a:t>
+            </a:r>
+            <a:endParaRPr lang="en-US" sz="1600" dirty="0"/>
+          </a:p>
+          <a:p>
+            <a:pPr>
+              <a:lnSpc>
+                <a:spcPts val="2400"/>
+              </a:lnSpc>
+            </a:pPr>
+            <a:r>
+              <a:rPr lang="en-US" sz="1600" b="1" dirty="0">
+                <a:solidFill>
+                  <a:srgbClr val="454545"/>
+                </a:solidFill>
+                <a:latin typeface="メイリオ" pitchFamily="34" charset="0"/>
+                <a:ea typeface="メイリオ" pitchFamily="34" charset="-122"/>
+                <a:cs typeface="メイリオ" pitchFamily="34" charset="-120"/>
+              </a:rPr>
+              <a:t>画像中央 / テキスト+図 / アイコングリッド / 強調</a:t>
+            </a:r>
+            <a:endParaRPr lang="en-US" sz="1600" dirty="0"/>
+          </a:p>
+        </p:txBody>
+      </p:sp>
+      <p:sp>
+        <p:nvSpPr>
+          <p:cNvPr id="5" name="Text 3"/>
+          <p:cNvSpPr/>
+          <p:nvPr/>
+        </p:nvSpPr>
+        <p:spPr>
+          <a:xfrm>
+            <a:off x="155448" y="6537960"/>
+            <a:ext cx="1097280" cy="182880"/>
           </a:xfrm>
           <a:prstGeom prst="rect">
             <a:avLst/>
@@ -6777,546 +7678,18 @@
           <a:bodyPr wrap="square" rtlCol="0" anchor="ctr"/>
           <a:lstStyle/>
           <a:p>
-            <a:pPr algn="ctr" indent="0" marL="0">
-              <a:buNone/>
-            </a:pPr>
-            <a:r>
-              <a:rPr lang="en-US" sz="2000" b="1" dirty="0">
-                <a:solidFill>
-                  <a:srgbClr val="FFFFFF"/>
+            <a:pPr indent="0" marL="0">
+              <a:buNone/>
+            </a:pPr>
+            <a:r>
+              <a:rPr lang="en-US" sz="800" dirty="0">
+                <a:solidFill>
+                  <a:srgbClr val="ED6A5B"/>
                 </a:solidFill>
                 <a:latin typeface="Century Gothic" pitchFamily="34" charset="0"/>
                 <a:ea typeface="Century Gothic" pitchFamily="34" charset="-122"/>
                 <a:cs typeface="Century Gothic" pitchFamily="34" charset="-120"/>
               </a:rPr>
-              <a:t>1</a:t>
-            </a:r>
-            <a:endParaRPr lang="en-US" sz="2000" dirty="0"/>
-          </a:p>
-        </p:txBody>
-      </p:sp>
-      <p:sp>
-        <p:nvSpPr>
-          <p:cNvPr id="7" name="Text 5"/>
-          <p:cNvSpPr/>
-          <p:nvPr/>
-        </p:nvSpPr>
-        <p:spPr>
-          <a:xfrm>
-            <a:off x="822960" y="3108960"/>
-            <a:ext cx="2499284" cy="457200"/>
-          </a:xfrm>
-          <a:prstGeom prst="rect">
-            <a:avLst/>
-          </a:prstGeom>
-          <a:noFill/>
-          <a:ln/>
-        </p:spPr>
-        <p:txBody>
-          <a:bodyPr wrap="square" rtlCol="0" anchor="ctr"/>
-          <a:lstStyle/>
-          <a:p>
-            <a:pPr algn="ctr" indent="0" marL="0">
-              <a:buNone/>
-            </a:pPr>
-            <a:r>
-              <a:rPr lang="en-US" sz="1600" b="1" dirty="0">
-                <a:solidFill>
-                  <a:srgbClr val="454545"/>
-                </a:solidFill>
-                <a:latin typeface="メイリオ" pitchFamily="34" charset="0"/>
-                <a:ea typeface="メイリオ" pitchFamily="34" charset="-122"/>
-                <a:cs typeface="メイリオ" pitchFamily="34" charset="-120"/>
-              </a:rPr>
-              <a:t>Clone</a:t>
-            </a:r>
-            <a:endParaRPr lang="en-US" sz="1600" dirty="0"/>
-          </a:p>
-        </p:txBody>
-      </p:sp>
-      <p:sp>
-        <p:nvSpPr>
-          <p:cNvPr id="8" name="Text 6"/>
-          <p:cNvSpPr/>
-          <p:nvPr/>
-        </p:nvSpPr>
-        <p:spPr>
-          <a:xfrm>
-            <a:off x="822960" y="3566160"/>
-            <a:ext cx="2499284" cy="914400"/>
-          </a:xfrm>
-          <a:prstGeom prst="rect">
-            <a:avLst/>
-          </a:prstGeom>
-          <a:noFill/>
-          <a:ln/>
-        </p:spPr>
-        <p:txBody>
-          <a:bodyPr wrap="square" rtlCol="0" anchor="ctr"/>
-          <a:lstStyle/>
-          <a:p>
-            <a:pPr algn="ctr" indent="0" marL="0">
-              <a:buNone/>
-            </a:pPr>
-            <a:r>
-              <a:rPr lang="en-US" sz="1050" dirty="0">
-                <a:solidFill>
-                  <a:srgbClr val="535353"/>
-                </a:solidFill>
-                <a:latin typeface="メイリオ" pitchFamily="34" charset="0"/>
-                <a:ea typeface="メイリオ" pitchFamily="34" charset="-122"/>
-                <a:cs typeface="メイリオ" pitchFamily="34" charset="-120"/>
-              </a:rPr>
-              <a:t>リポジトリをクローン</a:t>
-            </a:r>
-            <a:endParaRPr lang="en-US" sz="1050" dirty="0"/>
-          </a:p>
-        </p:txBody>
-      </p:sp>
-      <p:sp>
-        <p:nvSpPr>
-          <p:cNvPr id="9" name="Shape 7"/>
-          <p:cNvSpPr/>
-          <p:nvPr/>
-        </p:nvSpPr>
-        <p:spPr>
-          <a:xfrm>
-            <a:off x="4389006" y="2194560"/>
-            <a:ext cx="731520" cy="731520"/>
-          </a:xfrm>
-          <a:prstGeom prst="ellipse">
-            <a:avLst/>
-          </a:prstGeom>
-          <a:solidFill>
-            <a:srgbClr val="CBC269"/>
-          </a:solidFill>
-          <a:ln/>
-        </p:spPr>
-      </p:sp>
-      <p:sp>
-        <p:nvSpPr>
-          <p:cNvPr id="10" name="Text 8"/>
-          <p:cNvSpPr/>
-          <p:nvPr/>
-        </p:nvSpPr>
-        <p:spPr>
-          <a:xfrm>
-            <a:off x="4389006" y="2286000"/>
-            <a:ext cx="731520" cy="548640"/>
-          </a:xfrm>
-          <a:prstGeom prst="rect">
-            <a:avLst/>
-          </a:prstGeom>
-          <a:noFill/>
-          <a:ln/>
-        </p:spPr>
-        <p:txBody>
-          <a:bodyPr wrap="square" rtlCol="0" anchor="ctr"/>
-          <a:lstStyle/>
-          <a:p>
-            <a:pPr algn="ctr" indent="0" marL="0">
-              <a:buNone/>
-            </a:pPr>
-            <a:r>
-              <a:rPr lang="en-US" sz="2000" b="1" dirty="0">
-                <a:solidFill>
-                  <a:srgbClr val="FFFFFF"/>
-                </a:solidFill>
-                <a:latin typeface="Century Gothic" pitchFamily="34" charset="0"/>
-                <a:ea typeface="Century Gothic" pitchFamily="34" charset="-122"/>
-                <a:cs typeface="Century Gothic" pitchFamily="34" charset="-120"/>
-              </a:rPr>
-              <a:t>2</a:t>
-            </a:r>
-            <a:endParaRPr lang="en-US" sz="2000" dirty="0"/>
-          </a:p>
-        </p:txBody>
-      </p:sp>
-      <p:sp>
-        <p:nvSpPr>
-          <p:cNvPr id="11" name="Text 9"/>
-          <p:cNvSpPr/>
-          <p:nvPr/>
-        </p:nvSpPr>
-        <p:spPr>
-          <a:xfrm>
-            <a:off x="3505124" y="3108960"/>
-            <a:ext cx="2499284" cy="457200"/>
-          </a:xfrm>
-          <a:prstGeom prst="rect">
-            <a:avLst/>
-          </a:prstGeom>
-          <a:noFill/>
-          <a:ln/>
-        </p:spPr>
-        <p:txBody>
-          <a:bodyPr wrap="square" rtlCol="0" anchor="ctr"/>
-          <a:lstStyle/>
-          <a:p>
-            <a:pPr algn="ctr" indent="0" marL="0">
-              <a:buNone/>
-            </a:pPr>
-            <a:r>
-              <a:rPr lang="en-US" sz="1600" b="1" dirty="0">
-                <a:solidFill>
-                  <a:srgbClr val="454545"/>
-                </a:solidFill>
-                <a:latin typeface="メイリオ" pitchFamily="34" charset="0"/>
-                <a:ea typeface="メイリオ" pitchFamily="34" charset="-122"/>
-                <a:cs typeface="メイリオ" pitchFamily="34" charset="-120"/>
-              </a:rPr>
-              <a:t>Install</a:t>
-            </a:r>
-            <a:endParaRPr lang="en-US" sz="1600" dirty="0"/>
-          </a:p>
-        </p:txBody>
-      </p:sp>
-      <p:sp>
-        <p:nvSpPr>
-          <p:cNvPr id="12" name="Text 10"/>
-          <p:cNvSpPr/>
-          <p:nvPr/>
-        </p:nvSpPr>
-        <p:spPr>
-          <a:xfrm>
-            <a:off x="3505124" y="3566160"/>
-            <a:ext cx="2499284" cy="914400"/>
-          </a:xfrm>
-          <a:prstGeom prst="rect">
-            <a:avLst/>
-          </a:prstGeom>
-          <a:noFill/>
-          <a:ln/>
-        </p:spPr>
-        <p:txBody>
-          <a:bodyPr wrap="square" rtlCol="0" anchor="ctr"/>
-          <a:lstStyle/>
-          <a:p>
-            <a:pPr algn="ctr" indent="0" marL="0">
-              <a:buNone/>
-            </a:pPr>
-            <a:r>
-              <a:rPr lang="en-US" sz="1050" dirty="0">
-                <a:solidFill>
-                  <a:srgbClr val="535353"/>
-                </a:solidFill>
-                <a:latin typeface="メイリオ" pitchFamily="34" charset="0"/>
-                <a:ea typeface="メイリオ" pitchFamily="34" charset="-122"/>
-                <a:cs typeface="メイリオ" pitchFamily="34" charset="-120"/>
-              </a:rPr>
-              <a:t>npm install</a:t>
-            </a:r>
-            <a:endParaRPr lang="en-US" sz="1050" dirty="0"/>
-          </a:p>
-        </p:txBody>
-      </p:sp>
-      <p:sp>
-        <p:nvSpPr>
-          <p:cNvPr id="13" name="Shape 11"/>
-          <p:cNvSpPr/>
-          <p:nvPr/>
-        </p:nvSpPr>
-        <p:spPr>
-          <a:xfrm>
-            <a:off x="7071169" y="2194560"/>
-            <a:ext cx="731520" cy="731520"/>
-          </a:xfrm>
-          <a:prstGeom prst="ellipse">
-            <a:avLst/>
-          </a:prstGeom>
-          <a:solidFill>
-            <a:srgbClr val="CBC269"/>
-          </a:solidFill>
-          <a:ln/>
-        </p:spPr>
-      </p:sp>
-      <p:sp>
-        <p:nvSpPr>
-          <p:cNvPr id="14" name="Text 12"/>
-          <p:cNvSpPr/>
-          <p:nvPr/>
-        </p:nvSpPr>
-        <p:spPr>
-          <a:xfrm>
-            <a:off x="7071169" y="2286000"/>
-            <a:ext cx="731520" cy="548640"/>
-          </a:xfrm>
-          <a:prstGeom prst="rect">
-            <a:avLst/>
-          </a:prstGeom>
-          <a:noFill/>
-          <a:ln/>
-        </p:spPr>
-        <p:txBody>
-          <a:bodyPr wrap="square" rtlCol="0" anchor="ctr"/>
-          <a:lstStyle/>
-          <a:p>
-            <a:pPr algn="ctr" indent="0" marL="0">
-              <a:buNone/>
-            </a:pPr>
-            <a:r>
-              <a:rPr lang="en-US" sz="2000" b="1" dirty="0">
-                <a:solidFill>
-                  <a:srgbClr val="FFFFFF"/>
-                </a:solidFill>
-                <a:latin typeface="Century Gothic" pitchFamily="34" charset="0"/>
-                <a:ea typeface="Century Gothic" pitchFamily="34" charset="-122"/>
-                <a:cs typeface="Century Gothic" pitchFamily="34" charset="-120"/>
-              </a:rPr>
-              <a:t>3</a:t>
-            </a:r>
-            <a:endParaRPr lang="en-US" sz="2000" dirty="0"/>
-          </a:p>
-        </p:txBody>
-      </p:sp>
-      <p:sp>
-        <p:nvSpPr>
-          <p:cNvPr id="15" name="Text 13"/>
-          <p:cNvSpPr/>
-          <p:nvPr/>
-        </p:nvSpPr>
-        <p:spPr>
-          <a:xfrm>
-            <a:off x="6187288" y="3108960"/>
-            <a:ext cx="2499284" cy="457200"/>
-          </a:xfrm>
-          <a:prstGeom prst="rect">
-            <a:avLst/>
-          </a:prstGeom>
-          <a:noFill/>
-          <a:ln/>
-        </p:spPr>
-        <p:txBody>
-          <a:bodyPr wrap="square" rtlCol="0" anchor="ctr"/>
-          <a:lstStyle/>
-          <a:p>
-            <a:pPr algn="ctr" indent="0" marL="0">
-              <a:buNone/>
-            </a:pPr>
-            <a:r>
-              <a:rPr lang="en-US" sz="1600" b="1" dirty="0">
-                <a:solidFill>
-                  <a:srgbClr val="454545"/>
-                </a:solidFill>
-                <a:latin typeface="メイリオ" pitchFamily="34" charset="0"/>
-                <a:ea typeface="メイリオ" pitchFamily="34" charset="-122"/>
-                <a:cs typeface="メイリオ" pitchFamily="34" charset="-120"/>
-              </a:rPr>
-              <a:t>Generate</a:t>
-            </a:r>
-            <a:endParaRPr lang="en-US" sz="1600" dirty="0"/>
-          </a:p>
-        </p:txBody>
-      </p:sp>
-      <p:sp>
-        <p:nvSpPr>
-          <p:cNvPr id="16" name="Text 14"/>
-          <p:cNvSpPr/>
-          <p:nvPr/>
-        </p:nvSpPr>
-        <p:spPr>
-          <a:xfrm>
-            <a:off x="6187288" y="3566160"/>
-            <a:ext cx="2499284" cy="914400"/>
-          </a:xfrm>
-          <a:prstGeom prst="rect">
-            <a:avLst/>
-          </a:prstGeom>
-          <a:noFill/>
-          <a:ln/>
-        </p:spPr>
-        <p:txBody>
-          <a:bodyPr wrap="square" rtlCol="0" anchor="ctr"/>
-          <a:lstStyle/>
-          <a:p>
-            <a:pPr algn="ctr" indent="0" marL="0">
-              <a:buNone/>
-            </a:pPr>
-            <a:r>
-              <a:rPr lang="en-US" sz="1050" dirty="0">
-                <a:solidFill>
-                  <a:srgbClr val="535353"/>
-                </a:solidFill>
-                <a:latin typeface="メイリオ" pitchFamily="34" charset="0"/>
-                <a:ea typeface="メイリオ" pitchFamily="34" charset="-122"/>
-                <a:cs typeface="メイリオ" pitchFamily="34" charset="-120"/>
-              </a:rPr>
-              <a:t>npm run generate-template</a:t>
-            </a:r>
-            <a:endParaRPr lang="en-US" sz="1050" dirty="0"/>
-          </a:p>
-        </p:txBody>
-      </p:sp>
-      <p:sp>
-        <p:nvSpPr>
-          <p:cNvPr id="17" name="Shape 15"/>
-          <p:cNvSpPr/>
-          <p:nvPr/>
-        </p:nvSpPr>
-        <p:spPr>
-          <a:xfrm>
-            <a:off x="9753333" y="2194560"/>
-            <a:ext cx="731520" cy="731520"/>
-          </a:xfrm>
-          <a:prstGeom prst="ellipse">
-            <a:avLst/>
-          </a:prstGeom>
-          <a:solidFill>
-            <a:srgbClr val="CBC269"/>
-          </a:solidFill>
-          <a:ln/>
-        </p:spPr>
-      </p:sp>
-      <p:sp>
-        <p:nvSpPr>
-          <p:cNvPr id="18" name="Text 16"/>
-          <p:cNvSpPr/>
-          <p:nvPr/>
-        </p:nvSpPr>
-        <p:spPr>
-          <a:xfrm>
-            <a:off x="9753333" y="2286000"/>
-            <a:ext cx="731520" cy="548640"/>
-          </a:xfrm>
-          <a:prstGeom prst="rect">
-            <a:avLst/>
-          </a:prstGeom>
-          <a:noFill/>
-          <a:ln/>
-        </p:spPr>
-        <p:txBody>
-          <a:bodyPr wrap="square" rtlCol="0" anchor="ctr"/>
-          <a:lstStyle/>
-          <a:p>
-            <a:pPr algn="ctr" indent="0" marL="0">
-              <a:buNone/>
-            </a:pPr>
-            <a:r>
-              <a:rPr lang="en-US" sz="2000" b="1" dirty="0">
-                <a:solidFill>
-                  <a:srgbClr val="FFFFFF"/>
-                </a:solidFill>
-                <a:latin typeface="Century Gothic" pitchFamily="34" charset="0"/>
-                <a:ea typeface="Century Gothic" pitchFamily="34" charset="-122"/>
-                <a:cs typeface="Century Gothic" pitchFamily="34" charset="-120"/>
-              </a:rPr>
-              <a:t>4</a:t>
-            </a:r>
-            <a:endParaRPr lang="en-US" sz="2000" dirty="0"/>
-          </a:p>
-        </p:txBody>
-      </p:sp>
-      <p:sp>
-        <p:nvSpPr>
-          <p:cNvPr id="19" name="Text 17"/>
-          <p:cNvSpPr/>
-          <p:nvPr/>
-        </p:nvSpPr>
-        <p:spPr>
-          <a:xfrm>
-            <a:off x="8869451" y="3108960"/>
-            <a:ext cx="2499284" cy="457200"/>
-          </a:xfrm>
-          <a:prstGeom prst="rect">
-            <a:avLst/>
-          </a:prstGeom>
-          <a:noFill/>
-          <a:ln/>
-        </p:spPr>
-        <p:txBody>
-          <a:bodyPr wrap="square" rtlCol="0" anchor="ctr"/>
-          <a:lstStyle/>
-          <a:p>
-            <a:pPr algn="ctr" indent="0" marL="0">
-              <a:buNone/>
-            </a:pPr>
-            <a:r>
-              <a:rPr lang="en-US" sz="1600" b="1" dirty="0">
-                <a:solidFill>
-                  <a:srgbClr val="454545"/>
-                </a:solidFill>
-                <a:latin typeface="メイリオ" pitchFamily="34" charset="0"/>
-                <a:ea typeface="メイリオ" pitchFamily="34" charset="-122"/>
-                <a:cs typeface="メイリオ" pitchFamily="34" charset="-120"/>
-              </a:rPr>
-              <a:t>Done!</a:t>
-            </a:r>
-            <a:endParaRPr lang="en-US" sz="1600" dirty="0"/>
-          </a:p>
-        </p:txBody>
-      </p:sp>
-      <p:sp>
-        <p:nvSpPr>
-          <p:cNvPr id="20" name="Text 18"/>
-          <p:cNvSpPr/>
-          <p:nvPr/>
-        </p:nvSpPr>
-        <p:spPr>
-          <a:xfrm>
-            <a:off x="8869451" y="3566160"/>
-            <a:ext cx="2499284" cy="914400"/>
-          </a:xfrm>
-          <a:prstGeom prst="rect">
-            <a:avLst/>
-          </a:prstGeom>
-          <a:noFill/>
-          <a:ln/>
-        </p:spPr>
-        <p:txBody>
-          <a:bodyPr wrap="square" rtlCol="0" anchor="ctr"/>
-          <a:lstStyle/>
-          <a:p>
-            <a:pPr algn="ctr" indent="0" marL="0">
-              <a:buNone/>
-            </a:pPr>
-            <a:r>
-              <a:rPr lang="en-US" sz="1050" dirty="0">
-                <a:solidFill>
-                  <a:srgbClr val="535353"/>
-                </a:solidFill>
-                <a:latin typeface="メイリオ" pitchFamily="34" charset="0"/>
-                <a:ea typeface="メイリオ" pitchFamily="34" charset="-122"/>
-                <a:cs typeface="メイリオ" pitchFamily="34" charset="-120"/>
-              </a:rPr>
-              <a:t>すぐ使える</a:t>
-            </a:r>
-            <a:endParaRPr lang="en-US" sz="1050" dirty="0"/>
-          </a:p>
-        </p:txBody>
-      </p:sp>
-      <p:sp>
-        <p:nvSpPr>
-          <p:cNvPr id="21" name="Text 19"/>
-          <p:cNvSpPr/>
-          <p:nvPr/>
-        </p:nvSpPr>
-        <p:spPr>
-          <a:xfrm>
-            <a:off x="155448" y="6537960"/>
-            <a:ext cx="1097280" cy="182880"/>
-          </a:xfrm>
-          <a:prstGeom prst="rect">
-            <a:avLst/>
-          </a:prstGeom>
-          <a:noFill/>
-          <a:ln/>
-        </p:spPr>
-        <p:txBody>
-          <a:bodyPr wrap="square" rtlCol="0" anchor="ctr"/>
-          <a:lstStyle/>
-          <a:p>
-            <a:pPr indent="0" marL="0">
-              <a:buNone/>
-            </a:pPr>
-            <a:r>
-              <a:rPr lang="en-US" sz="800" dirty="0">
-                <a:solidFill>
-                  <a:srgbClr val="ED6A5B"/>
-                </a:solidFill>
-                <a:latin typeface="Century Gothic" pitchFamily="34" charset="0"/>
-                <a:ea typeface="Century Gothic" pitchFamily="34" charset="-122"/>
-                <a:cs typeface="Century Gothic" pitchFamily="34" charset="-120"/>
-              </a:rPr>
               <a:t>Strictly Confidential</a:t>
             </a:r>
             <a:endParaRPr lang="en-US" sz="800" dirty="0"/>
@@ -7325,7 +7698,7 @@
       </p:sp>
       <p:sp>
         <p:nvSpPr>
-          <p:cNvPr id="22" name="Text 20"/>
+          <p:cNvPr id="6" name="Text 4"/>
           <p:cNvSpPr/>
           <p:nvPr/>
         </p:nvSpPr>

</xml_diff>